<commit_message>
L2: esercizi sullo slicing, omissioni e passo
- task: nuova parte sullo slicing (testi, omissioni, passo, prevedi e verifica, da Excel a iloc); documentazione spostata tra i bonus
- slide: omissioni e passo
- dispensa: omissioni e passo

Co-Authored-By: Claude Opus 5.5 <noreply@anthropic.com>
Claude-Session: https://claude.ai/code/session_014CzWDFXvYNxqLeD99LSN3G
</commit_message>
<xml_diff>
--- a/lezioni/L02_conosci_il_dataset/slide.pptx
+++ b/lezioni/L02_conosci_il_dataset/slide.pptx
@@ -18,9 +18,10 @@
     <p:sldId id="266" r:id="rId12"/>
     <p:sldId id="267" r:id="rId13"/>
     <p:sldId id="268" r:id="rId14"/>
+    <p:sldId id="269" r:id="rId15"/>
   </p:sldIdLst>
   <p:notesMasterIdLst>
-    <p:notesMasterId r:id="rId15"/>
+    <p:notesMasterId r:id="rId16"/>
   </p:notesMasterIdLst>
   <p:sldSz cx="12192000" cy="6858000"/>
   <p:notesSz cx="6858000" cy="12192000"/>
@@ -119,13 +120,13 @@
   <p:extLst>
     <p:ext uri="{521415D9-36F7-43E2-AB2F-B90AF26B5E84}">
       <p14:sectionLst xmlns:p14="http://schemas.microsoft.com/office/powerpoint/2010/main">
-        <p14:section name="Apertura" id="{60ed819d-5cf3-f0d9-7389-49f22bd2869e}">
+        <p14:section name="Apertura" id="{3a38cc86-cf05-e9fb-a4ef-23a512308108}">
           <p14:sldIdLst>
             <p14:sldId id="256"/>
             <p14:sldId id="257"/>
           </p14:sldIdLst>
         </p14:section>
-        <p14:section name="Spiegazione" id="{1225102d-2042-a945-dae1-9da7f6fc8097}">
+        <p14:section name="Spiegazione" id="{cf0d9cdd-4781-96b3-e551-4e4b7564b4e5}">
           <p14:sldIdLst>
             <p14:sldId id="258"/>
             <p14:sldId id="259"/>
@@ -136,16 +137,17 @@
             <p14:sldId id="264"/>
             <p14:sldId id="265"/>
             <p14:sldId id="266"/>
-          </p14:sldIdLst>
-        </p14:section>
-        <p14:section name="Task" id="{8a6eb5d2-4bdf-c282-8f07-de1057aceae3}">
-          <p14:sldIdLst>
             <p14:sldId id="267"/>
           </p14:sldIdLst>
         </p14:section>
-        <p14:section name="Chiusura" id="{d1ad9fb2-fd71-6fd7-777f-da0b673fe5a5}">
+        <p14:section name="Task" id="{31601de4-f41f-7268-df87-cf496545d941}">
           <p14:sldIdLst>
             <p14:sldId id="268"/>
+          </p14:sldIdLst>
+        </p14:section>
+        <p14:section name="Chiusura" id="{9a63ecdf-81fd-f530-63cc-7044e8a69550}">
+          <p14:sldIdLst>
+            <p14:sldId id="269"/>
           </p14:sldIdLst>
         </p14:section>
       </p14:sectionLst>
@@ -640,7 +642,7 @@
           <a:p>
             <a:r>
               <a:rPr lang="en-US" dirty="0"/>
-              <a:t>DEMO: aprire la pagina della documentazione dei DataFrame, mostrare l'elenco dei metodi, cliccarne uno (head) e far vedere la struttura: parametri, cosa restituisce, esempi in fondo. Gli esempi in fondo sono la parte più utile.</a:t>
+              <a:t>Concetto astratto, tenerlo leggero. In Colab: scrivere df. e premere Tab per vedere tutto quello che si può chiedere.</a:t>
             </a:r>
             <a:endParaRPr lang="en-US" dirty="0"/>
           </a:p>
@@ -728,7 +730,7 @@
           <a:p>
             <a:r>
               <a:rPr lang="en-US" dirty="0"/>
-              <a:t>Non serve memorizzare i comandi: serve ricordarsi le domande. I comandi si cercano.</a:t>
+              <a:t>DEMO: aprire la pagina della documentazione dei DataFrame, mostrare l'elenco dei metodi, cliccarne uno (head) e far vedere la struttura: parametri, cosa restituisce, esempi in fondo. Gli esempi in fondo sono la parte più utile.</a:t>
             </a:r>
             <a:endParaRPr lang="en-US" dirty="0"/>
           </a:p>
@@ -816,7 +818,7 @@
           <a:p>
             <a:r>
               <a:rPr lang="en-US" dirty="0"/>
-              <a:t>Durante il task: segnarsi chi trova i problemi e come. Molti al passo 7 vedranno 'n.d.' come massimo e non si faranno domande: è il punto del debrief.</a:t>
+              <a:t>Non serve memorizzare i comandi: serve ricordarsi le domande. I comandi si cercano.</a:t>
             </a:r>
             <a:endParaRPr lang="en-US" dirty="0"/>
           </a:p>
@@ -904,7 +906,7 @@
           <a:p>
             <a:r>
               <a:rPr lang="en-US" dirty="0"/>
-              <a:t>Le lezioni Kaggle: Creating, Reading and Writing; Indexing, Selecting &amp; Assigning.</a:t>
+              <a:t>Durante il task: segnarsi chi trova i problemi e come. Molti al passo 7 vedranno 'n.d.' come massimo e non si faranno domande: è il punto del debrief.</a:t>
             </a:r>
             <a:endParaRPr lang="en-US" dirty="0"/>
           </a:p>
@@ -928,6 +930,94 @@
             <a:fld id="{F7021451-1387-4CA6-816F-3879F97B5CBC}" type="slidenum">
               <a:rPr lang="en-US"/>
               <a:t>13</a:t>
+            </a:fld>
+            <a:endParaRPr lang="en-US"/>
+          </a:p>
+        </p:txBody>
+      </p:sp>
+    </p:spTree>
+    <p:extLst>
+      <p:ext uri="{BB962C8B-B14F-4D97-AF65-F5344CB8AC3E}">
+        <p14:creationId xmlns:p14="http://schemas.microsoft.com/office/powerpoint/2010/main" val="1024086991"/>
+      </p:ext>
+    </p:extLst>
+  </p:cSld>
+  <p:clrMapOvr>
+    <a:masterClrMapping/>
+  </p:clrMapOvr>
+</p:notes>
+</file>
+
+<file path=ppt/notesSlides/notesSlide14.xml><?xml version="1.0" encoding="utf-8"?>
+<p:notes xmlns:a="http://schemas.openxmlformats.org/drawingml/2006/main" xmlns:r="http://schemas.openxmlformats.org/officeDocument/2006/relationships" xmlns:p="http://schemas.openxmlformats.org/presentationml/2006/main">
+  <p:cSld>
+    <p:spTree>
+      <p:nvGrpSpPr>
+        <p:cNvPr id="1" name=""/>
+        <p:cNvGrpSpPr/>
+        <p:nvPr/>
+      </p:nvGrpSpPr>
+      <p:grpSpPr>
+        <a:xfrm>
+          <a:off x="0" y="0"/>
+          <a:ext cx="0" cy="0"/>
+          <a:chOff x="0" y="0"/>
+          <a:chExt cx="0" cy="0"/>
+        </a:xfrm>
+      </p:grpSpPr>
+      <p:sp>
+        <p:nvSpPr>
+          <p:cNvPr id="2" name="Slide Image Placeholder 1"/>
+          <p:cNvSpPr>
+            <a:spLocks noGrp="1" noRot="1" noChangeAspect="1"/>
+          </p:cNvSpPr>
+          <p:nvPr>
+            <p:ph type="sldImg"/>
+          </p:nvPr>
+        </p:nvSpPr>
+        <p:spPr/>
+      </p:sp>
+      <p:sp>
+        <p:nvSpPr>
+          <p:cNvPr id="3" name="Notes Placeholder 2"/>
+          <p:cNvSpPr>
+            <a:spLocks noGrp="1"/>
+          </p:cNvSpPr>
+          <p:nvPr>
+            <p:ph type="body" idx="1"/>
+          </p:nvPr>
+        </p:nvSpPr>
+        <p:spPr/>
+        <p:txBody>
+          <a:bodyPr/>
+          <a:lstStyle/>
+          <a:p>
+            <a:r>
+              <a:rPr lang="en-US" dirty="0"/>
+              <a:t>Le lezioni Kaggle: Creating, Reading and Writing; Indexing, Selecting &amp; Assigning.</a:t>
+            </a:r>
+            <a:endParaRPr lang="en-US" dirty="0"/>
+          </a:p>
+        </p:txBody>
+      </p:sp>
+      <p:sp>
+        <p:nvSpPr>
+          <p:cNvPr id="4" name="Slide Number Placeholder 3"/>
+          <p:cNvSpPr>
+            <a:spLocks noGrp="1"/>
+          </p:cNvSpPr>
+          <p:nvPr>
+            <p:ph type="sldNum" sz="quarter" idx="10"/>
+          </p:nvPr>
+        </p:nvSpPr>
+        <p:spPr/>
+        <p:txBody>
+          <a:bodyPr/>
+          <a:lstStyle/>
+          <a:p>
+            <a:fld id="{F7021451-1387-4CA6-816F-3879F97B5CBC}" type="slidenum">
+              <a:rPr lang="en-US"/>
+              <a:t>14</a:t>
             </a:fld>
             <a:endParaRPr lang="en-US"/>
           </a:p>
@@ -1520,7 +1610,7 @@
           <a:p>
             <a:r>
               <a:rPr lang="en-US" dirty="0"/>
-              <a:t>La tabella nella slide è semplificata (colonne scelte per chiarezza). Dal vivo: aprire imprese.xlsx in Excel o Google Sheets accanto a Colab, selezionare A2:C6, poi eseguire df.iloc[0:5, 0:3]: sono le stesse celle. Con i tagli della slide precedente: il taglio 0 sta sotto l'intestazione, il taglio 5 dopo la quinta riga di dati.</a:t>
+              <a:t>Il passo serve raramente con i DataFrame (df.iloc[::100] per vedere una riga ogni 100 è il caso tipico), ma [::-1] per invertire è un classico che troveranno ovunque.</a:t>
             </a:r>
             <a:endParaRPr lang="en-US" dirty="0"/>
           </a:p>
@@ -1608,7 +1698,7 @@
           <a:p>
             <a:r>
               <a:rPr lang="en-US" dirty="0"/>
-              <a:t>Concetto astratto, tenerlo leggero. In Colab: scrivere df. e premere Tab per vedere tutto quello che si può chiedere.</a:t>
+              <a:t>La tabella nella slide è semplificata (colonne scelte per chiarezza). Dal vivo: aprire imprese.xlsx in Excel o Google Sheets accanto a Colab, selezionare A2:C6, poi eseguire df.iloc[0:5, 0:3]: sono le stesse celle. Con i tagli della slide precedente: il taglio 0 sta sotto l'intestazione, il taglio 5 dopo la quinta riga di dati.</a:t>
             </a:r>
             <a:endParaRPr lang="en-US" dirty="0"/>
           </a:p>
@@ -2527,7 +2617,7 @@
                   <a:srgbClr val="0F4C5C"/>
                 </a:solidFill>
               </a:rPr>
-              <a:t>Come scoprire cosa sa fare un oggetto</a:t>
+              <a:t>Fare domande a un oggetto</a:t>
             </a:r>
             <a:endParaRPr lang="en-US" sz="3600" dirty="0"/>
           </a:p>
@@ -2535,18 +2625,187 @@
       </p:sp>
       <p:sp>
         <p:nvSpPr>
-          <p:cNvPr id="3" name="Shape 1"/>
+          <p:cNvPr id="3" name="Text 1"/>
+          <p:cNvSpPr txBox="1"/>
+          <p:nvPr/>
+        </p:nvSpPr>
+        <p:spPr>
+          <a:xfrm>
+            <a:off x="548640" y="1645920"/>
+            <a:ext cx="5349240" cy="457200"/>
+          </a:xfrm>
+          <a:prstGeom prst="rect">
+            <a:avLst/>
+          </a:prstGeom>
+          <a:noFill/>
+          <a:ln/>
+        </p:spPr>
+        <p:txBody>
+          <a:bodyPr wrap="square" lIns="0" tIns="0" rIns="0" bIns="0" rtlCol="0" anchor="ctr"/>
+          <a:lstStyle/>
+          <a:p>
+            <a:pPr indent="0" marL="0">
+              <a:buNone/>
+            </a:pPr>
+            <a:r>
+              <a:rPr lang="en-US" sz="2600" b="1" dirty="0">
+                <a:solidFill>
+                  <a:srgbClr val="0F4C5C"/>
+                </a:solidFill>
+              </a:rPr>
+              <a:t>Metodo</a:t>
+            </a:r>
+            <a:endParaRPr lang="en-US" sz="2600" dirty="0"/>
+          </a:p>
+        </p:txBody>
+      </p:sp>
+      <p:sp>
+        <p:nvSpPr>
+          <p:cNvPr id="4" name="Text 2"/>
+          <p:cNvSpPr txBox="1"/>
+          <p:nvPr/>
+        </p:nvSpPr>
+        <p:spPr>
+          <a:xfrm>
+            <a:off x="548640" y="2103120"/>
+            <a:ext cx="5349240" cy="411480"/>
+          </a:xfrm>
+          <a:prstGeom prst="rect">
+            <a:avLst/>
+          </a:prstGeom>
+          <a:noFill/>
+          <a:ln/>
+        </p:spPr>
+        <p:txBody>
+          <a:bodyPr wrap="square" lIns="0" tIns="0" rIns="0" bIns="0" rtlCol="0" anchor="ctr"/>
+          <a:lstStyle/>
+          <a:p>
+            <a:pPr indent="0" marL="0">
+              <a:buNone/>
+            </a:pPr>
+            <a:r>
+              <a:rPr lang="en-US" sz="1800" dirty="0">
+                <a:solidFill>
+                  <a:srgbClr val="5C6F7B"/>
+                </a:solidFill>
+              </a:rPr>
+              <a:t>un'azione: ha le parentesi</a:t>
+            </a:r>
+            <a:endParaRPr lang="en-US" sz="1800" dirty="0"/>
+          </a:p>
+        </p:txBody>
+      </p:sp>
+      <p:sp>
+        <p:nvSpPr>
+          <p:cNvPr id="5" name="card-code"/>
           <p:cNvSpPr/>
           <p:nvPr/>
         </p:nvSpPr>
         <p:spPr>
           <a:xfrm>
-            <a:off x="548640" y="1737360"/>
-            <a:ext cx="3474720" cy="3108960"/>
+            <a:off x="548640" y="2697480"/>
+            <a:ext cx="5349240" cy="1188720"/>
           </a:xfrm>
           <a:prstGeom prst="roundRect">
             <a:avLst>
-              <a:gd name="adj" fmla="val 3529"/>
+              <a:gd name="adj" fmla="val 9231"/>
+            </a:avLst>
+          </a:prstGeom>
+          <a:solidFill>
+            <a:srgbClr val="1F2A30"/>
+          </a:solidFill>
+          <a:ln/>
+        </p:spPr>
+      </p:sp>
+      <p:sp>
+        <p:nvSpPr>
+          <p:cNvPr id="6" name="Text 4"/>
+          <p:cNvSpPr txBox="1"/>
+          <p:nvPr/>
+        </p:nvSpPr>
+        <p:spPr>
+          <a:xfrm>
+            <a:off x="777240" y="2834640"/>
+            <a:ext cx="1828800" cy="274320"/>
+          </a:xfrm>
+          <a:prstGeom prst="rect">
+            <a:avLst/>
+          </a:prstGeom>
+          <a:noFill/>
+          <a:ln/>
+        </p:spPr>
+        <p:txBody>
+          <a:bodyPr wrap="square" lIns="0" tIns="0" rIns="0" bIns="0" rtlCol="0" anchor="ctr"/>
+          <a:lstStyle/>
+          <a:p>
+            <a:pPr indent="0" marL="0">
+              <a:buNone/>
+            </a:pPr>
+            <a:r>
+              <a:rPr lang="en-US" sz="1100" b="1" spc="200" kern="0" dirty="0">
+                <a:solidFill>
+                  <a:srgbClr val="E09F3E"/>
+                </a:solidFill>
+              </a:rPr>
+              <a:t>PYTHON</a:t>
+            </a:r>
+            <a:endParaRPr lang="en-US" sz="1100" dirty="0"/>
+          </a:p>
+        </p:txBody>
+      </p:sp>
+      <p:sp>
+        <p:nvSpPr>
+          <p:cNvPr id="7" name="Text 5"/>
+          <p:cNvSpPr txBox="1"/>
+          <p:nvPr/>
+        </p:nvSpPr>
+        <p:spPr>
+          <a:xfrm>
+            <a:off x="777240" y="3154680"/>
+            <a:ext cx="4892040" cy="594360"/>
+          </a:xfrm>
+          <a:prstGeom prst="rect">
+            <a:avLst/>
+          </a:prstGeom>
+          <a:noFill/>
+          <a:ln/>
+        </p:spPr>
+        <p:txBody>
+          <a:bodyPr wrap="square" lIns="0" tIns="0" rIns="0" bIns="0" rtlCol="0" anchor="t"/>
+          <a:lstStyle/>
+          <a:p>
+            <a:pPr indent="0" marL="0">
+              <a:buNone/>
+            </a:pPr>
+            <a:r>
+              <a:rPr lang="en-US" sz="2200" dirty="0">
+                <a:solidFill>
+                  <a:srgbClr val="FFFFFF"/>
+                </a:solidFill>
+                <a:latin typeface="Courier New" pitchFamily="34" charset="0"/>
+                <a:ea typeface="Courier New" pitchFamily="34" charset="-122"/>
+                <a:cs typeface="Courier New" pitchFamily="34" charset="-120"/>
+              </a:rPr>
+              <a:t>df.head(3)</a:t>
+            </a:r>
+            <a:endParaRPr lang="en-US" sz="2200" dirty="0"/>
+          </a:p>
+        </p:txBody>
+      </p:sp>
+      <p:sp>
+        <p:nvSpPr>
+          <p:cNvPr id="8" name="card-out"/>
+          <p:cNvSpPr/>
+          <p:nvPr/>
+        </p:nvSpPr>
+        <p:spPr>
+          <a:xfrm>
+            <a:off x="548640" y="4069080"/>
+            <a:ext cx="5349240" cy="1188720"/>
+          </a:xfrm>
+          <a:prstGeom prst="roundRect">
+            <a:avLst>
+              <a:gd name="adj" fmla="val 9231"/>
             </a:avLst>
           </a:prstGeom>
           <a:solidFill>
@@ -2557,58 +2816,14 @@
       </p:sp>
       <p:sp>
         <p:nvSpPr>
-          <p:cNvPr id="4" name="Shape 2"/>
-          <p:cNvSpPr/>
-          <p:nvPr/>
-        </p:nvSpPr>
-        <p:spPr>
-          <a:xfrm>
-            <a:off x="868680" y="2057400"/>
-            <a:ext cx="914400" cy="914400"/>
-          </a:xfrm>
-          <a:prstGeom prst="ellipse">
-            <a:avLst/>
-          </a:prstGeom>
-          <a:solidFill>
-            <a:srgbClr val="FFFFFF"/>
-          </a:solidFill>
-          <a:ln/>
-        </p:spPr>
-      </p:sp>
-      <p:pic>
-        <p:nvPicPr>
-          <p:cNvPr id="5" name="Image 0" descr="preencoded.png">    </p:cNvPr>
-          <p:cNvPicPr>
-            <a:picLocks noChangeAspect="1"/>
-          </p:cNvPicPr>
-          <p:nvPr/>
-        </p:nvPicPr>
-        <p:blipFill>
-          <a:blip r:embed="rId1"/>
-          <a:stretch>
-            <a:fillRect/>
-          </a:stretch>
-        </p:blipFill>
-        <p:spPr>
-          <a:xfrm>
-            <a:off x="1115568" y="2304288"/>
-            <a:ext cx="420624" cy="420624"/>
-          </a:xfrm>
-          <a:prstGeom prst="rect">
-            <a:avLst/>
-          </a:prstGeom>
-        </p:spPr>
-      </p:pic>
-      <p:sp>
-        <p:nvSpPr>
-          <p:cNvPr id="6" name="Text 3"/>
-          <p:cNvSpPr txBox="1"/>
-          <p:nvPr/>
-        </p:nvSpPr>
-        <p:spPr>
-          <a:xfrm>
-            <a:off x="868680" y="3200400"/>
-            <a:ext cx="2834640" cy="502920"/>
+          <p:cNvPr id="9" name="Text 7"/>
+          <p:cNvSpPr txBox="1"/>
+          <p:nvPr/>
+        </p:nvSpPr>
+        <p:spPr>
+          <a:xfrm>
+            <a:off x="777240" y="4206240"/>
+            <a:ext cx="1828800" cy="274320"/>
           </a:xfrm>
           <a:prstGeom prst="rect">
             <a:avLst/>
@@ -2624,7 +2839,43 @@
               <a:buNone/>
             </a:pPr>
             <a:r>
-              <a:rPr lang="en-US" sz="2200" b="1" dirty="0">
+              <a:rPr lang="en-US" sz="1100" b="1" spc="200" kern="0" dirty="0">
+                <a:solidFill>
+                  <a:srgbClr val="5C6F7B"/>
+                </a:solidFill>
+              </a:rPr>
+              <a:t>OUTPUT</a:t>
+            </a:r>
+            <a:endParaRPr lang="en-US" sz="1100" dirty="0"/>
+          </a:p>
+        </p:txBody>
+      </p:sp>
+      <p:sp>
+        <p:nvSpPr>
+          <p:cNvPr id="10" name="Text 8"/>
+          <p:cNvSpPr txBox="1"/>
+          <p:nvPr/>
+        </p:nvSpPr>
+        <p:spPr>
+          <a:xfrm>
+            <a:off x="777240" y="4526280"/>
+            <a:ext cx="4892040" cy="594360"/>
+          </a:xfrm>
+          <a:prstGeom prst="rect">
+            <a:avLst/>
+          </a:prstGeom>
+          <a:noFill/>
+          <a:ln/>
+        </p:spPr>
+        <p:txBody>
+          <a:bodyPr wrap="square" lIns="0" tIns="0" rIns="0" bIns="0" rtlCol="0" anchor="t"/>
+          <a:lstStyle/>
+          <a:p>
+            <a:pPr indent="0" marL="0">
+              <a:buNone/>
+            </a:pPr>
+            <a:r>
+              <a:rPr lang="en-US" sz="2000" dirty="0">
                 <a:solidFill>
                   <a:srgbClr val="1F2A30"/>
                 </a:solidFill>
@@ -2632,62 +2883,195 @@
                 <a:ea typeface="Courier New" pitchFamily="34" charset="-122"/>
                 <a:cs typeface="Courier New" pitchFamily="34" charset="-120"/>
               </a:rPr>
-              <a:t>df. + Tab</a:t>
-            </a:r>
-            <a:endParaRPr lang="en-US" sz="2200" dirty="0"/>
-          </a:p>
-        </p:txBody>
-      </p:sp>
-      <p:sp>
-        <p:nvSpPr>
-          <p:cNvPr id="7" name="Text 4"/>
-          <p:cNvSpPr txBox="1"/>
-          <p:nvPr/>
-        </p:nvSpPr>
-        <p:spPr>
-          <a:xfrm>
-            <a:off x="868680" y="3749040"/>
-            <a:ext cx="2834640" cy="914400"/>
-          </a:xfrm>
-          <a:prstGeom prst="rect">
-            <a:avLst/>
-          </a:prstGeom>
-          <a:noFill/>
-          <a:ln/>
-        </p:spPr>
-        <p:txBody>
-          <a:bodyPr wrap="square" lIns="0" tIns="0" rIns="0" bIns="0" rtlCol="0" anchor="t"/>
+              <a:t>le prime 3 righe</a:t>
+            </a:r>
+            <a:endParaRPr lang="en-US" sz="2000" dirty="0"/>
+          </a:p>
+        </p:txBody>
+      </p:sp>
+      <p:sp>
+        <p:nvSpPr>
+          <p:cNvPr id="11" name="Text 9"/>
+          <p:cNvSpPr txBox="1"/>
+          <p:nvPr/>
+        </p:nvSpPr>
+        <p:spPr>
+          <a:xfrm>
+            <a:off x="6263640" y="1645920"/>
+            <a:ext cx="5349240" cy="457200"/>
+          </a:xfrm>
+          <a:prstGeom prst="rect">
+            <a:avLst/>
+          </a:prstGeom>
+          <a:noFill/>
+          <a:ln/>
+        </p:spPr>
+        <p:txBody>
+          <a:bodyPr wrap="square" lIns="0" tIns="0" rIns="0" bIns="0" rtlCol="0" anchor="ctr"/>
           <a:lstStyle/>
           <a:p>
             <a:pPr indent="0" marL="0">
               <a:buNone/>
             </a:pPr>
             <a:r>
-              <a:rPr lang="en-US" sz="1600" dirty="0">
+              <a:rPr lang="en-US" sz="2600" b="1" dirty="0">
+                <a:solidFill>
+                  <a:srgbClr val="0F4C5C"/>
+                </a:solidFill>
+              </a:rPr>
+              <a:t>Attributo</a:t>
+            </a:r>
+            <a:endParaRPr lang="en-US" sz="2600" dirty="0"/>
+          </a:p>
+        </p:txBody>
+      </p:sp>
+      <p:sp>
+        <p:nvSpPr>
+          <p:cNvPr id="12" name="Text 10"/>
+          <p:cNvSpPr txBox="1"/>
+          <p:nvPr/>
+        </p:nvSpPr>
+        <p:spPr>
+          <a:xfrm>
+            <a:off x="6263640" y="2103120"/>
+            <a:ext cx="5349240" cy="411480"/>
+          </a:xfrm>
+          <a:prstGeom prst="rect">
+            <a:avLst/>
+          </a:prstGeom>
+          <a:noFill/>
+          <a:ln/>
+        </p:spPr>
+        <p:txBody>
+          <a:bodyPr wrap="square" lIns="0" tIns="0" rIns="0" bIns="0" rtlCol="0" anchor="ctr"/>
+          <a:lstStyle/>
+          <a:p>
+            <a:pPr indent="0" marL="0">
+              <a:buNone/>
+            </a:pPr>
+            <a:r>
+              <a:rPr lang="en-US" sz="1800" dirty="0">
                 <a:solidFill>
                   <a:srgbClr val="5C6F7B"/>
                 </a:solidFill>
               </a:rPr>
-              <a:t>In Colab: l'elenco di tutto quello che puoi chiedere</a:t>
-            </a:r>
-            <a:endParaRPr lang="en-US" sz="1600" dirty="0"/>
-          </a:p>
-        </p:txBody>
-      </p:sp>
-      <p:sp>
-        <p:nvSpPr>
-          <p:cNvPr id="8" name="Shape 5"/>
+              <a:t>un'informazione: niente parentesi</a:t>
+            </a:r>
+            <a:endParaRPr lang="en-US" sz="1800" dirty="0"/>
+          </a:p>
+        </p:txBody>
+      </p:sp>
+      <p:sp>
+        <p:nvSpPr>
+          <p:cNvPr id="13" name="card-code"/>
           <p:cNvSpPr/>
           <p:nvPr/>
         </p:nvSpPr>
         <p:spPr>
           <a:xfrm>
-            <a:off x="4343400" y="1737360"/>
-            <a:ext cx="3474720" cy="3108960"/>
+            <a:off x="6263640" y="2697480"/>
+            <a:ext cx="5349240" cy="1188720"/>
           </a:xfrm>
           <a:prstGeom prst="roundRect">
             <a:avLst>
-              <a:gd name="adj" fmla="val 3529"/>
+              <a:gd name="adj" fmla="val 9231"/>
+            </a:avLst>
+          </a:prstGeom>
+          <a:solidFill>
+            <a:srgbClr val="1F2A30"/>
+          </a:solidFill>
+          <a:ln/>
+        </p:spPr>
+      </p:sp>
+      <p:sp>
+        <p:nvSpPr>
+          <p:cNvPr id="14" name="Text 12"/>
+          <p:cNvSpPr txBox="1"/>
+          <p:nvPr/>
+        </p:nvSpPr>
+        <p:spPr>
+          <a:xfrm>
+            <a:off x="6492240" y="2834640"/>
+            <a:ext cx="1828800" cy="274320"/>
+          </a:xfrm>
+          <a:prstGeom prst="rect">
+            <a:avLst/>
+          </a:prstGeom>
+          <a:noFill/>
+          <a:ln/>
+        </p:spPr>
+        <p:txBody>
+          <a:bodyPr wrap="square" lIns="0" tIns="0" rIns="0" bIns="0" rtlCol="0" anchor="ctr"/>
+          <a:lstStyle/>
+          <a:p>
+            <a:pPr indent="0" marL="0">
+              <a:buNone/>
+            </a:pPr>
+            <a:r>
+              <a:rPr lang="en-US" sz="1100" b="1" spc="200" kern="0" dirty="0">
+                <a:solidFill>
+                  <a:srgbClr val="E09F3E"/>
+                </a:solidFill>
+              </a:rPr>
+              <a:t>PYTHON</a:t>
+            </a:r>
+            <a:endParaRPr lang="en-US" sz="1100" dirty="0"/>
+          </a:p>
+        </p:txBody>
+      </p:sp>
+      <p:sp>
+        <p:nvSpPr>
+          <p:cNvPr id="15" name="Text 13"/>
+          <p:cNvSpPr txBox="1"/>
+          <p:nvPr/>
+        </p:nvSpPr>
+        <p:spPr>
+          <a:xfrm>
+            <a:off x="6492240" y="3154680"/>
+            <a:ext cx="4892040" cy="594360"/>
+          </a:xfrm>
+          <a:prstGeom prst="rect">
+            <a:avLst/>
+          </a:prstGeom>
+          <a:noFill/>
+          <a:ln/>
+        </p:spPr>
+        <p:txBody>
+          <a:bodyPr wrap="square" lIns="0" tIns="0" rIns="0" bIns="0" rtlCol="0" anchor="t"/>
+          <a:lstStyle/>
+          <a:p>
+            <a:pPr indent="0" marL="0">
+              <a:buNone/>
+            </a:pPr>
+            <a:r>
+              <a:rPr lang="en-US" sz="2200" dirty="0">
+                <a:solidFill>
+                  <a:srgbClr val="FFFFFF"/>
+                </a:solidFill>
+                <a:latin typeface="Courier New" pitchFamily="34" charset="0"/>
+                <a:ea typeface="Courier New" pitchFamily="34" charset="-122"/>
+                <a:cs typeface="Courier New" pitchFamily="34" charset="-120"/>
+              </a:rPr>
+              <a:t>df.shape</a:t>
+            </a:r>
+            <a:endParaRPr lang="en-US" sz="2200" dirty="0"/>
+          </a:p>
+        </p:txBody>
+      </p:sp>
+      <p:sp>
+        <p:nvSpPr>
+          <p:cNvPr id="16" name="card-out"/>
+          <p:cNvSpPr/>
+          <p:nvPr/>
+        </p:nvSpPr>
+        <p:spPr>
+          <a:xfrm>
+            <a:off x="6263640" y="4069080"/>
+            <a:ext cx="5349240" cy="1188720"/>
+          </a:xfrm>
+          <a:prstGeom prst="roundRect">
+            <a:avLst>
+              <a:gd name="adj" fmla="val 9231"/>
             </a:avLst>
           </a:prstGeom>
           <a:solidFill>
@@ -2698,58 +3082,14 @@
       </p:sp>
       <p:sp>
         <p:nvSpPr>
-          <p:cNvPr id="9" name="Shape 6"/>
-          <p:cNvSpPr/>
-          <p:nvPr/>
-        </p:nvSpPr>
-        <p:spPr>
-          <a:xfrm>
-            <a:off x="4663440" y="2057400"/>
-            <a:ext cx="914400" cy="914400"/>
-          </a:xfrm>
-          <a:prstGeom prst="ellipse">
-            <a:avLst/>
-          </a:prstGeom>
-          <a:solidFill>
-            <a:srgbClr val="FFFFFF"/>
-          </a:solidFill>
-          <a:ln/>
-        </p:spPr>
-      </p:sp>
-      <p:pic>
-        <p:nvPicPr>
-          <p:cNvPr id="10" name="Image 1" descr="preencoded.png">    </p:cNvPr>
-          <p:cNvPicPr>
-            <a:picLocks noChangeAspect="1"/>
-          </p:cNvPicPr>
-          <p:nvPr/>
-        </p:nvPicPr>
-        <p:blipFill>
-          <a:blip r:embed="rId2"/>
-          <a:stretch>
-            <a:fillRect/>
-          </a:stretch>
-        </p:blipFill>
-        <p:spPr>
-          <a:xfrm>
-            <a:off x="4910328" y="2304288"/>
-            <a:ext cx="420624" cy="420624"/>
-          </a:xfrm>
-          <a:prstGeom prst="rect">
-            <a:avLst/>
-          </a:prstGeom>
-        </p:spPr>
-      </p:pic>
-      <p:sp>
-        <p:nvSpPr>
-          <p:cNvPr id="11" name="Text 7"/>
-          <p:cNvSpPr txBox="1"/>
-          <p:nvPr/>
-        </p:nvSpPr>
-        <p:spPr>
-          <a:xfrm>
-            <a:off x="4663440" y="3200400"/>
-            <a:ext cx="2834640" cy="502920"/>
+          <p:cNvPr id="17" name="Text 15"/>
+          <p:cNvSpPr txBox="1"/>
+          <p:nvPr/>
+        </p:nvSpPr>
+        <p:spPr>
+          <a:xfrm>
+            <a:off x="6492240" y="4206240"/>
+            <a:ext cx="1828800" cy="274320"/>
           </a:xfrm>
           <a:prstGeom prst="rect">
             <a:avLst/>
@@ -2765,7 +3105,43 @@
               <a:buNone/>
             </a:pPr>
             <a:r>
-              <a:rPr lang="en-US" sz="2200" b="1" dirty="0">
+              <a:rPr lang="en-US" sz="1100" b="1" spc="200" kern="0" dirty="0">
+                <a:solidFill>
+                  <a:srgbClr val="5C6F7B"/>
+                </a:solidFill>
+              </a:rPr>
+              <a:t>OUTPUT</a:t>
+            </a:r>
+            <a:endParaRPr lang="en-US" sz="1100" dirty="0"/>
+          </a:p>
+        </p:txBody>
+      </p:sp>
+      <p:sp>
+        <p:nvSpPr>
+          <p:cNvPr id="18" name="Text 16"/>
+          <p:cNvSpPr txBox="1"/>
+          <p:nvPr/>
+        </p:nvSpPr>
+        <p:spPr>
+          <a:xfrm>
+            <a:off x="6492240" y="4526280"/>
+            <a:ext cx="4892040" cy="594360"/>
+          </a:xfrm>
+          <a:prstGeom prst="rect">
+            <a:avLst/>
+          </a:prstGeom>
+          <a:noFill/>
+          <a:ln/>
+        </p:spPr>
+        <p:txBody>
+          <a:bodyPr wrap="square" lIns="0" tIns="0" rIns="0" bIns="0" rtlCol="0" anchor="t"/>
+          <a:lstStyle/>
+          <a:p>
+            <a:pPr indent="0" marL="0">
+              <a:buNone/>
+            </a:pPr>
+            <a:r>
+              <a:rPr lang="en-US" sz="2000" dirty="0">
                 <a:solidFill>
                   <a:srgbClr val="1F2A30"/>
                 </a:solidFill>
@@ -2773,217 +3149,43 @@
                 <a:ea typeface="Courier New" pitchFamily="34" charset="-122"/>
                 <a:cs typeface="Courier New" pitchFamily="34" charset="-120"/>
               </a:rPr>
-              <a:t>help(df.head)</a:t>
-            </a:r>
-            <a:endParaRPr lang="en-US" sz="2200" dirty="0"/>
-          </a:p>
-        </p:txBody>
-      </p:sp>
-      <p:sp>
-        <p:nvSpPr>
-          <p:cNvPr id="12" name="Text 8"/>
-          <p:cNvSpPr txBox="1"/>
-          <p:nvPr/>
-        </p:nvSpPr>
-        <p:spPr>
-          <a:xfrm>
-            <a:off x="4663440" y="3749040"/>
-            <a:ext cx="2834640" cy="914400"/>
-          </a:xfrm>
-          <a:prstGeom prst="rect">
-            <a:avLst/>
-          </a:prstGeom>
-          <a:noFill/>
-          <a:ln/>
-        </p:spPr>
-        <p:txBody>
-          <a:bodyPr wrap="square" lIns="0" tIns="0" rIns="0" bIns="0" rtlCol="0" anchor="t"/>
+              <a:t>(2515, 9)</a:t>
+            </a:r>
+            <a:endParaRPr lang="en-US" sz="2000" dirty="0"/>
+          </a:p>
+        </p:txBody>
+      </p:sp>
+      <p:sp>
+        <p:nvSpPr>
+          <p:cNvPr id="19" name="Text 17"/>
+          <p:cNvSpPr txBox="1"/>
+          <p:nvPr/>
+        </p:nvSpPr>
+        <p:spPr>
+          <a:xfrm>
+            <a:off x="548640" y="5532120"/>
+            <a:ext cx="11064240" cy="457200"/>
+          </a:xfrm>
+          <a:prstGeom prst="rect">
+            <a:avLst/>
+          </a:prstGeom>
+          <a:noFill/>
+          <a:ln/>
+        </p:spPr>
+        <p:txBody>
+          <a:bodyPr wrap="square" lIns="0" tIns="0" rIns="0" bIns="0" rtlCol="0" anchor="ctr"/>
           <a:lstStyle/>
           <a:p>
             <a:pPr indent="0" marL="0">
               <a:buNone/>
             </a:pPr>
             <a:r>
-              <a:rPr lang="en-US" sz="1600" dirty="0">
-                <a:solidFill>
-                  <a:srgbClr val="5C6F7B"/>
-                </a:solidFill>
-              </a:rPr>
-              <a:t>La spiegazione di un metodo, con esempi</a:t>
-            </a:r>
-            <a:endParaRPr lang="en-US" sz="1600" dirty="0"/>
-          </a:p>
-        </p:txBody>
-      </p:sp>
-      <p:sp>
-        <p:nvSpPr>
-          <p:cNvPr id="13" name="Shape 9"/>
-          <p:cNvSpPr/>
-          <p:nvPr/>
-        </p:nvSpPr>
-        <p:spPr>
-          <a:xfrm>
-            <a:off x="8138160" y="1737360"/>
-            <a:ext cx="3474720" cy="3108960"/>
-          </a:xfrm>
-          <a:prstGeom prst="roundRect">
-            <a:avLst>
-              <a:gd name="adj" fmla="val 3529"/>
-            </a:avLst>
-          </a:prstGeom>
-          <a:solidFill>
-            <a:srgbClr val="EEF3F4"/>
-          </a:solidFill>
-          <a:ln/>
-        </p:spPr>
-      </p:sp>
-      <p:sp>
-        <p:nvSpPr>
-          <p:cNvPr id="14" name="Shape 10"/>
-          <p:cNvSpPr/>
-          <p:nvPr/>
-        </p:nvSpPr>
-        <p:spPr>
-          <a:xfrm>
-            <a:off x="8458200" y="2057400"/>
-            <a:ext cx="914400" cy="914400"/>
-          </a:xfrm>
-          <a:prstGeom prst="ellipse">
-            <a:avLst/>
-          </a:prstGeom>
-          <a:solidFill>
-            <a:srgbClr val="FFFFFF"/>
-          </a:solidFill>
-          <a:ln/>
-        </p:spPr>
-      </p:sp>
-      <p:pic>
-        <p:nvPicPr>
-          <p:cNvPr id="15" name="Image 2" descr="preencoded.png">    </p:cNvPr>
-          <p:cNvPicPr>
-            <a:picLocks noChangeAspect="1"/>
-          </p:cNvPicPr>
-          <p:nvPr/>
-        </p:nvPicPr>
-        <p:blipFill>
-          <a:blip r:embed="rId3"/>
-          <a:stretch>
-            <a:fillRect/>
-          </a:stretch>
-        </p:blipFill>
-        <p:spPr>
-          <a:xfrm>
-            <a:off x="8705088" y="2304288"/>
-            <a:ext cx="420624" cy="420624"/>
-          </a:xfrm>
-          <a:prstGeom prst="rect">
-            <a:avLst/>
-          </a:prstGeom>
-        </p:spPr>
-      </p:pic>
-      <p:sp>
-        <p:nvSpPr>
-          <p:cNvPr id="16" name="Text 11"/>
-          <p:cNvSpPr txBox="1"/>
-          <p:nvPr/>
-        </p:nvSpPr>
-        <p:spPr>
-          <a:xfrm>
-            <a:off x="8458200" y="3200400"/>
-            <a:ext cx="2834640" cy="502920"/>
-          </a:xfrm>
-          <a:prstGeom prst="rect">
-            <a:avLst/>
-          </a:prstGeom>
-          <a:noFill/>
-          <a:ln/>
-        </p:spPr>
-        <p:txBody>
-          <a:bodyPr wrap="square" lIns="0" tIns="0" rIns="0" bIns="0" rtlCol="0" anchor="ctr"/>
-          <a:lstStyle/>
-          <a:p>
-            <a:pPr indent="0" marL="0">
-              <a:buNone/>
-            </a:pPr>
-            <a:r>
-              <a:rPr lang="en-US" sz="2200" b="1" dirty="0">
-                <a:solidFill>
-                  <a:srgbClr val="1F2A30"/>
-                </a:solidFill>
-              </a:rPr>
-              <a:t>La documentazione</a:t>
-            </a:r>
-            <a:endParaRPr lang="en-US" sz="2200" dirty="0"/>
-          </a:p>
-        </p:txBody>
-      </p:sp>
-      <p:sp>
-        <p:nvSpPr>
-          <p:cNvPr id="17" name="Text 12"/>
-          <p:cNvSpPr txBox="1"/>
-          <p:nvPr/>
-        </p:nvSpPr>
-        <p:spPr>
-          <a:xfrm>
-            <a:off x="8458200" y="3749040"/>
-            <a:ext cx="2834640" cy="914400"/>
-          </a:xfrm>
-          <a:prstGeom prst="rect">
-            <a:avLst/>
-          </a:prstGeom>
-          <a:noFill/>
-          <a:ln/>
-        </p:spPr>
-        <p:txBody>
-          <a:bodyPr wrap="square" lIns="0" tIns="0" rIns="0" bIns="0" rtlCol="0" anchor="t"/>
-          <a:lstStyle/>
-          <a:p>
-            <a:pPr indent="0" marL="0">
-              <a:buNone/>
-            </a:pPr>
-            <a:r>
-              <a:rPr lang="en-US" sz="1600" dirty="0">
-                <a:solidFill>
-                  <a:srgbClr val="5C6F7B"/>
-                </a:solidFill>
-              </a:rPr>
-              <a:t>pandas.pydata.org → API reference → DataFrame</a:t>
-            </a:r>
-            <a:endParaRPr lang="en-US" sz="1600" dirty="0"/>
-          </a:p>
-        </p:txBody>
-      </p:sp>
-      <p:sp>
-        <p:nvSpPr>
-          <p:cNvPr id="18" name="Text 13"/>
-          <p:cNvSpPr txBox="1"/>
-          <p:nvPr/>
-        </p:nvSpPr>
-        <p:spPr>
-          <a:xfrm>
-            <a:off x="548640" y="5257800"/>
-            <a:ext cx="11064240" cy="457200"/>
-          </a:xfrm>
-          <a:prstGeom prst="rect">
-            <a:avLst/>
-          </a:prstGeom>
-          <a:noFill/>
-          <a:ln/>
-        </p:spPr>
-        <p:txBody>
-          <a:bodyPr wrap="square" lIns="0" tIns="0" rIns="0" bIns="0" rtlCol="0" anchor="ctr"/>
-          <a:lstStyle/>
-          <a:p>
-            <a:pPr indent="0" marL="0">
-              <a:buNone/>
-            </a:pPr>
-            <a:r>
               <a:rPr lang="en-US" sz="1800" i="1" dirty="0">
                 <a:solidFill>
                   <a:srgbClr val="0F4C5C"/>
                 </a:solidFill>
               </a:rPr>
-              <a:t>Nessuno conosce tutti i metodi. Si cercano, ogni giorno, anche dopo anni.</a:t>
+              <a:t>df è un oggetto: dati, più tutte le cose che puoi chiedergli. Il punto le collega.</a:t>
             </a:r>
             <a:endParaRPr lang="en-US" sz="1800" dirty="0"/>
           </a:p>
@@ -3091,7 +3293,7 @@
                   <a:srgbClr val="0F4C5C"/>
                 </a:solidFill>
               </a:rPr>
-              <a:t>Le domande da fare sempre a un dataset</a:t>
+              <a:t>Come scoprire cosa sa fare un oggetto</a:t>
             </a:r>
             <a:endParaRPr lang="en-US" sz="3600" dirty="0"/>
           </a:p>
@@ -3106,11 +3308,11 @@
         <p:spPr>
           <a:xfrm>
             <a:off x="548640" y="1737360"/>
-            <a:ext cx="5440680" cy="1645920"/>
+            <a:ext cx="3474720" cy="3108960"/>
           </a:xfrm>
           <a:prstGeom prst="roundRect">
             <a:avLst>
-              <a:gd name="adj" fmla="val 6667"/>
+              <a:gd name="adj" fmla="val 3529"/>
             </a:avLst>
           </a:prstGeom>
           <a:solidFill>
@@ -3127,8 +3329,8 @@
         </p:nvSpPr>
         <p:spPr>
           <a:xfrm>
-            <a:off x="822960" y="2194560"/>
-            <a:ext cx="731520" cy="731520"/>
+            <a:off x="868680" y="2057400"/>
+            <a:ext cx="914400" cy="914400"/>
           </a:xfrm>
           <a:prstGeom prst="ellipse">
             <a:avLst/>
@@ -3139,52 +3341,40 @@
           <a:ln/>
         </p:spPr>
       </p:sp>
-      <p:sp>
-        <p:nvSpPr>
-          <p:cNvPr id="5" name="Text 3"/>
-          <p:cNvSpPr txBox="1"/>
-          <p:nvPr/>
-        </p:nvSpPr>
-        <p:spPr>
-          <a:xfrm>
-            <a:off x="822960" y="2194560"/>
-            <a:ext cx="731520" cy="731520"/>
-          </a:xfrm>
-          <a:prstGeom prst="rect">
-            <a:avLst/>
-          </a:prstGeom>
-          <a:noFill/>
-          <a:ln/>
-        </p:spPr>
-        <p:txBody>
-          <a:bodyPr wrap="square" lIns="0" tIns="0" rIns="0" bIns="0" rtlCol="0" anchor="ctr"/>
-          <a:lstStyle/>
-          <a:p>
-            <a:pPr algn="ctr" indent="0" marL="0">
-              <a:buNone/>
-            </a:pPr>
-            <a:r>
-              <a:rPr lang="en-US" sz="2080" b="1" dirty="0">
-                <a:solidFill>
-                  <a:srgbClr val="0F4C5C"/>
-                </a:solidFill>
-              </a:rPr>
-              <a:t>1</a:t>
-            </a:r>
-            <a:endParaRPr lang="en-US" sz="2080" dirty="0"/>
-          </a:p>
-        </p:txBody>
-      </p:sp>
-      <p:sp>
-        <p:nvSpPr>
-          <p:cNvPr id="6" name="Text 4"/>
-          <p:cNvSpPr txBox="1"/>
-          <p:nvPr/>
-        </p:nvSpPr>
-        <p:spPr>
-          <a:xfrm>
-            <a:off x="1828800" y="2057400"/>
-            <a:ext cx="3931920" cy="502920"/>
+      <p:pic>
+        <p:nvPicPr>
+          <p:cNvPr id="5" name="Image 0" descr="preencoded.png">    </p:cNvPr>
+          <p:cNvPicPr>
+            <a:picLocks noChangeAspect="1"/>
+          </p:cNvPicPr>
+          <p:nvPr/>
+        </p:nvPicPr>
+        <p:blipFill>
+          <a:blip r:embed="rId1"/>
+          <a:stretch>
+            <a:fillRect/>
+          </a:stretch>
+        </p:blipFill>
+        <p:spPr>
+          <a:xfrm>
+            <a:off x="1115568" y="2304288"/>
+            <a:ext cx="420624" cy="420624"/>
+          </a:xfrm>
+          <a:prstGeom prst="rect">
+            <a:avLst/>
+          </a:prstGeom>
+        </p:spPr>
+      </p:pic>
+      <p:sp>
+        <p:nvSpPr>
+          <p:cNvPr id="6" name="Text 3"/>
+          <p:cNvSpPr txBox="1"/>
+          <p:nvPr/>
+        </p:nvSpPr>
+        <p:spPr>
+          <a:xfrm>
+            <a:off x="868680" y="3200400"/>
+            <a:ext cx="2834640" cy="502920"/>
           </a:xfrm>
           <a:prstGeom prst="rect">
             <a:avLst/>
@@ -3200,70 +3390,70 @@
               <a:buNone/>
             </a:pPr>
             <a:r>
-              <a:rPr lang="en-US" sz="2100" b="1" dirty="0">
+              <a:rPr lang="en-US" sz="2200" b="1" dirty="0">
                 <a:solidFill>
                   <a:srgbClr val="1F2A30"/>
-                </a:solidFill>
-              </a:rPr>
-              <a:t>Quanto è grande?</a:t>
-            </a:r>
-            <a:endParaRPr lang="en-US" sz="2100" dirty="0"/>
-          </a:p>
-        </p:txBody>
-      </p:sp>
-      <p:sp>
-        <p:nvSpPr>
-          <p:cNvPr id="7" name="Text 5"/>
-          <p:cNvSpPr txBox="1"/>
-          <p:nvPr/>
-        </p:nvSpPr>
-        <p:spPr>
-          <a:xfrm>
-            <a:off x="1828800" y="2606040"/>
-            <a:ext cx="3931920" cy="457200"/>
-          </a:xfrm>
-          <a:prstGeom prst="rect">
-            <a:avLst/>
-          </a:prstGeom>
-          <a:noFill/>
-          <a:ln/>
-        </p:spPr>
-        <p:txBody>
-          <a:bodyPr wrap="square" lIns="0" tIns="0" rIns="0" bIns="0" rtlCol="0" anchor="ctr"/>
-          <a:lstStyle/>
-          <a:p>
-            <a:pPr indent="0" marL="0">
-              <a:buNone/>
-            </a:pPr>
-            <a:r>
-              <a:rPr lang="en-US" sz="1700" dirty="0">
-                <a:solidFill>
-                  <a:srgbClr val="0F4C5C"/>
                 </a:solidFill>
                 <a:latin typeface="Courier New" pitchFamily="34" charset="0"/>
                 <a:ea typeface="Courier New" pitchFamily="34" charset="-122"/>
                 <a:cs typeface="Courier New" pitchFamily="34" charset="-120"/>
               </a:rPr>
-              <a:t>df.shape</a:t>
-            </a:r>
-            <a:endParaRPr lang="en-US" sz="1700" dirty="0"/>
-          </a:p>
-        </p:txBody>
-      </p:sp>
-      <p:sp>
-        <p:nvSpPr>
-          <p:cNvPr id="8" name="Shape 6"/>
+              <a:t>df. + Tab</a:t>
+            </a:r>
+            <a:endParaRPr lang="en-US" sz="2200" dirty="0"/>
+          </a:p>
+        </p:txBody>
+      </p:sp>
+      <p:sp>
+        <p:nvSpPr>
+          <p:cNvPr id="7" name="Text 4"/>
+          <p:cNvSpPr txBox="1"/>
+          <p:nvPr/>
+        </p:nvSpPr>
+        <p:spPr>
+          <a:xfrm>
+            <a:off x="868680" y="3749040"/>
+            <a:ext cx="2834640" cy="914400"/>
+          </a:xfrm>
+          <a:prstGeom prst="rect">
+            <a:avLst/>
+          </a:prstGeom>
+          <a:noFill/>
+          <a:ln/>
+        </p:spPr>
+        <p:txBody>
+          <a:bodyPr wrap="square" lIns="0" tIns="0" rIns="0" bIns="0" rtlCol="0" anchor="t"/>
+          <a:lstStyle/>
+          <a:p>
+            <a:pPr indent="0" marL="0">
+              <a:buNone/>
+            </a:pPr>
+            <a:r>
+              <a:rPr lang="en-US" sz="1600" dirty="0">
+                <a:solidFill>
+                  <a:srgbClr val="5C6F7B"/>
+                </a:solidFill>
+              </a:rPr>
+              <a:t>In Colab: l'elenco di tutto quello che puoi chiedere</a:t>
+            </a:r>
+            <a:endParaRPr lang="en-US" sz="1600" dirty="0"/>
+          </a:p>
+        </p:txBody>
+      </p:sp>
+      <p:sp>
+        <p:nvSpPr>
+          <p:cNvPr id="8" name="Shape 5"/>
           <p:cNvSpPr/>
           <p:nvPr/>
         </p:nvSpPr>
         <p:spPr>
           <a:xfrm>
-            <a:off x="6172200" y="1737360"/>
-            <a:ext cx="5440680" cy="1645920"/>
+            <a:off x="4343400" y="1737360"/>
+            <a:ext cx="3474720" cy="3108960"/>
           </a:xfrm>
           <a:prstGeom prst="roundRect">
             <a:avLst>
-              <a:gd name="adj" fmla="val 6667"/>
+              <a:gd name="adj" fmla="val 3529"/>
             </a:avLst>
           </a:prstGeom>
           <a:solidFill>
@@ -3274,14 +3464,14 @@
       </p:sp>
       <p:sp>
         <p:nvSpPr>
-          <p:cNvPr id="9" name="Shape 7"/>
+          <p:cNvPr id="9" name="Shape 6"/>
           <p:cNvSpPr/>
           <p:nvPr/>
         </p:nvSpPr>
         <p:spPr>
           <a:xfrm>
-            <a:off x="6446520" y="2194560"/>
-            <a:ext cx="731520" cy="731520"/>
+            <a:off x="4663440" y="2057400"/>
+            <a:ext cx="914400" cy="914400"/>
           </a:xfrm>
           <a:prstGeom prst="ellipse">
             <a:avLst/>
@@ -3292,52 +3482,40 @@
           <a:ln/>
         </p:spPr>
       </p:sp>
-      <p:sp>
-        <p:nvSpPr>
-          <p:cNvPr id="10" name="Text 8"/>
-          <p:cNvSpPr txBox="1"/>
-          <p:nvPr/>
-        </p:nvSpPr>
-        <p:spPr>
-          <a:xfrm>
-            <a:off x="6446520" y="2194560"/>
-            <a:ext cx="731520" cy="731520"/>
-          </a:xfrm>
-          <a:prstGeom prst="rect">
-            <a:avLst/>
-          </a:prstGeom>
-          <a:noFill/>
-          <a:ln/>
-        </p:spPr>
-        <p:txBody>
-          <a:bodyPr wrap="square" lIns="0" tIns="0" rIns="0" bIns="0" rtlCol="0" anchor="ctr"/>
-          <a:lstStyle/>
-          <a:p>
-            <a:pPr algn="ctr" indent="0" marL="0">
-              <a:buNone/>
-            </a:pPr>
-            <a:r>
-              <a:rPr lang="en-US" sz="2080" b="1" dirty="0">
-                <a:solidFill>
-                  <a:srgbClr val="0F4C5C"/>
-                </a:solidFill>
-              </a:rPr>
-              <a:t>2</a:t>
-            </a:r>
-            <a:endParaRPr lang="en-US" sz="2080" dirty="0"/>
-          </a:p>
-        </p:txBody>
-      </p:sp>
-      <p:sp>
-        <p:nvSpPr>
-          <p:cNvPr id="11" name="Text 9"/>
-          <p:cNvSpPr txBox="1"/>
-          <p:nvPr/>
-        </p:nvSpPr>
-        <p:spPr>
-          <a:xfrm>
-            <a:off x="7452360" y="2057400"/>
-            <a:ext cx="3931920" cy="502920"/>
+      <p:pic>
+        <p:nvPicPr>
+          <p:cNvPr id="10" name="Image 1" descr="preencoded.png">    </p:cNvPr>
+          <p:cNvPicPr>
+            <a:picLocks noChangeAspect="1"/>
+          </p:cNvPicPr>
+          <p:nvPr/>
+        </p:nvPicPr>
+        <p:blipFill>
+          <a:blip r:embed="rId2"/>
+          <a:stretch>
+            <a:fillRect/>
+          </a:stretch>
+        </p:blipFill>
+        <p:spPr>
+          <a:xfrm>
+            <a:off x="4910328" y="2304288"/>
+            <a:ext cx="420624" cy="420624"/>
+          </a:xfrm>
+          <a:prstGeom prst="rect">
+            <a:avLst/>
+          </a:prstGeom>
+        </p:spPr>
+      </p:pic>
+      <p:sp>
+        <p:nvSpPr>
+          <p:cNvPr id="11" name="Text 7"/>
+          <p:cNvSpPr txBox="1"/>
+          <p:nvPr/>
+        </p:nvSpPr>
+        <p:spPr>
+          <a:xfrm>
+            <a:off x="4663440" y="3200400"/>
+            <a:ext cx="2834640" cy="502920"/>
           </a:xfrm>
           <a:prstGeom prst="rect">
             <a:avLst/>
@@ -3353,70 +3531,70 @@
               <a:buNone/>
             </a:pPr>
             <a:r>
-              <a:rPr lang="en-US" sz="2100" b="1" dirty="0">
+              <a:rPr lang="en-US" sz="2200" b="1" dirty="0">
                 <a:solidFill>
                   <a:srgbClr val="1F2A30"/>
-                </a:solidFill>
-              </a:rPr>
-              <a:t>Di che tipo sono le colonne?</a:t>
-            </a:r>
-            <a:endParaRPr lang="en-US" sz="2100" dirty="0"/>
-          </a:p>
-        </p:txBody>
-      </p:sp>
-      <p:sp>
-        <p:nvSpPr>
-          <p:cNvPr id="12" name="Text 10"/>
-          <p:cNvSpPr txBox="1"/>
-          <p:nvPr/>
-        </p:nvSpPr>
-        <p:spPr>
-          <a:xfrm>
-            <a:off x="7452360" y="2606040"/>
-            <a:ext cx="3931920" cy="457200"/>
-          </a:xfrm>
-          <a:prstGeom prst="rect">
-            <a:avLst/>
-          </a:prstGeom>
-          <a:noFill/>
-          <a:ln/>
-        </p:spPr>
-        <p:txBody>
-          <a:bodyPr wrap="square" lIns="0" tIns="0" rIns="0" bIns="0" rtlCol="0" anchor="ctr"/>
-          <a:lstStyle/>
-          <a:p>
-            <a:pPr indent="0" marL="0">
-              <a:buNone/>
-            </a:pPr>
-            <a:r>
-              <a:rPr lang="en-US" sz="1700" dirty="0">
-                <a:solidFill>
-                  <a:srgbClr val="0F4C5C"/>
                 </a:solidFill>
                 <a:latin typeface="Courier New" pitchFamily="34" charset="0"/>
                 <a:ea typeface="Courier New" pitchFamily="34" charset="-122"/>
                 <a:cs typeface="Courier New" pitchFamily="34" charset="-120"/>
               </a:rPr>
-              <a:t>df.dtypes</a:t>
-            </a:r>
-            <a:endParaRPr lang="en-US" sz="1700" dirty="0"/>
-          </a:p>
-        </p:txBody>
-      </p:sp>
-      <p:sp>
-        <p:nvSpPr>
-          <p:cNvPr id="13" name="Shape 11"/>
+              <a:t>help(df.head)</a:t>
+            </a:r>
+            <a:endParaRPr lang="en-US" sz="2200" dirty="0"/>
+          </a:p>
+        </p:txBody>
+      </p:sp>
+      <p:sp>
+        <p:nvSpPr>
+          <p:cNvPr id="12" name="Text 8"/>
+          <p:cNvSpPr txBox="1"/>
+          <p:nvPr/>
+        </p:nvSpPr>
+        <p:spPr>
+          <a:xfrm>
+            <a:off x="4663440" y="3749040"/>
+            <a:ext cx="2834640" cy="914400"/>
+          </a:xfrm>
+          <a:prstGeom prst="rect">
+            <a:avLst/>
+          </a:prstGeom>
+          <a:noFill/>
+          <a:ln/>
+        </p:spPr>
+        <p:txBody>
+          <a:bodyPr wrap="square" lIns="0" tIns="0" rIns="0" bIns="0" rtlCol="0" anchor="t"/>
+          <a:lstStyle/>
+          <a:p>
+            <a:pPr indent="0" marL="0">
+              <a:buNone/>
+            </a:pPr>
+            <a:r>
+              <a:rPr lang="en-US" sz="1600" dirty="0">
+                <a:solidFill>
+                  <a:srgbClr val="5C6F7B"/>
+                </a:solidFill>
+              </a:rPr>
+              <a:t>La spiegazione di un metodo, con esempi</a:t>
+            </a:r>
+            <a:endParaRPr lang="en-US" sz="1600" dirty="0"/>
+          </a:p>
+        </p:txBody>
+      </p:sp>
+      <p:sp>
+        <p:nvSpPr>
+          <p:cNvPr id="13" name="Shape 9"/>
           <p:cNvSpPr/>
           <p:nvPr/>
         </p:nvSpPr>
         <p:spPr>
           <a:xfrm>
-            <a:off x="548640" y="3657600"/>
-            <a:ext cx="5440680" cy="1645920"/>
+            <a:off x="8138160" y="1737360"/>
+            <a:ext cx="3474720" cy="3108960"/>
           </a:xfrm>
           <a:prstGeom prst="roundRect">
             <a:avLst>
-              <a:gd name="adj" fmla="val 6667"/>
+              <a:gd name="adj" fmla="val 3529"/>
             </a:avLst>
           </a:prstGeom>
           <a:solidFill>
@@ -3427,14 +3605,14 @@
       </p:sp>
       <p:sp>
         <p:nvSpPr>
-          <p:cNvPr id="14" name="Shape 12"/>
+          <p:cNvPr id="14" name="Shape 10"/>
           <p:cNvSpPr/>
           <p:nvPr/>
         </p:nvSpPr>
         <p:spPr>
           <a:xfrm>
-            <a:off x="822960" y="4114800"/>
-            <a:ext cx="731520" cy="731520"/>
+            <a:off x="8458200" y="2057400"/>
+            <a:ext cx="914400" cy="914400"/>
           </a:xfrm>
           <a:prstGeom prst="ellipse">
             <a:avLst/>
@@ -3445,301 +3623,133 @@
           <a:ln/>
         </p:spPr>
       </p:sp>
-      <p:sp>
-        <p:nvSpPr>
-          <p:cNvPr id="15" name="Text 13"/>
-          <p:cNvSpPr txBox="1"/>
-          <p:nvPr/>
-        </p:nvSpPr>
-        <p:spPr>
-          <a:xfrm>
-            <a:off x="822960" y="4114800"/>
-            <a:ext cx="731520" cy="731520"/>
-          </a:xfrm>
-          <a:prstGeom prst="rect">
-            <a:avLst/>
-          </a:prstGeom>
-          <a:noFill/>
-          <a:ln/>
-        </p:spPr>
-        <p:txBody>
-          <a:bodyPr wrap="square" lIns="0" tIns="0" rIns="0" bIns="0" rtlCol="0" anchor="ctr"/>
-          <a:lstStyle/>
-          <a:p>
-            <a:pPr algn="ctr" indent="0" marL="0">
-              <a:buNone/>
-            </a:pPr>
-            <a:r>
-              <a:rPr lang="en-US" sz="2080" b="1" dirty="0">
+      <p:pic>
+        <p:nvPicPr>
+          <p:cNvPr id="15" name="Image 2" descr="preencoded.png">    </p:cNvPr>
+          <p:cNvPicPr>
+            <a:picLocks noChangeAspect="1"/>
+          </p:cNvPicPr>
+          <p:nvPr/>
+        </p:nvPicPr>
+        <p:blipFill>
+          <a:blip r:embed="rId3"/>
+          <a:stretch>
+            <a:fillRect/>
+          </a:stretch>
+        </p:blipFill>
+        <p:spPr>
+          <a:xfrm>
+            <a:off x="8705088" y="2304288"/>
+            <a:ext cx="420624" cy="420624"/>
+          </a:xfrm>
+          <a:prstGeom prst="rect">
+            <a:avLst/>
+          </a:prstGeom>
+        </p:spPr>
+      </p:pic>
+      <p:sp>
+        <p:nvSpPr>
+          <p:cNvPr id="16" name="Text 11"/>
+          <p:cNvSpPr txBox="1"/>
+          <p:nvPr/>
+        </p:nvSpPr>
+        <p:spPr>
+          <a:xfrm>
+            <a:off x="8458200" y="3200400"/>
+            <a:ext cx="2834640" cy="502920"/>
+          </a:xfrm>
+          <a:prstGeom prst="rect">
+            <a:avLst/>
+          </a:prstGeom>
+          <a:noFill/>
+          <a:ln/>
+        </p:spPr>
+        <p:txBody>
+          <a:bodyPr wrap="square" lIns="0" tIns="0" rIns="0" bIns="0" rtlCol="0" anchor="ctr"/>
+          <a:lstStyle/>
+          <a:p>
+            <a:pPr indent="0" marL="0">
+              <a:buNone/>
+            </a:pPr>
+            <a:r>
+              <a:rPr lang="en-US" sz="2200" b="1" dirty="0">
+                <a:solidFill>
+                  <a:srgbClr val="1F2A30"/>
+                </a:solidFill>
+              </a:rPr>
+              <a:t>La documentazione</a:t>
+            </a:r>
+            <a:endParaRPr lang="en-US" sz="2200" dirty="0"/>
+          </a:p>
+        </p:txBody>
+      </p:sp>
+      <p:sp>
+        <p:nvSpPr>
+          <p:cNvPr id="17" name="Text 12"/>
+          <p:cNvSpPr txBox="1"/>
+          <p:nvPr/>
+        </p:nvSpPr>
+        <p:spPr>
+          <a:xfrm>
+            <a:off x="8458200" y="3749040"/>
+            <a:ext cx="2834640" cy="914400"/>
+          </a:xfrm>
+          <a:prstGeom prst="rect">
+            <a:avLst/>
+          </a:prstGeom>
+          <a:noFill/>
+          <a:ln/>
+        </p:spPr>
+        <p:txBody>
+          <a:bodyPr wrap="square" lIns="0" tIns="0" rIns="0" bIns="0" rtlCol="0" anchor="t"/>
+          <a:lstStyle/>
+          <a:p>
+            <a:pPr indent="0" marL="0">
+              <a:buNone/>
+            </a:pPr>
+            <a:r>
+              <a:rPr lang="en-US" sz="1600" dirty="0">
+                <a:solidFill>
+                  <a:srgbClr val="5C6F7B"/>
+                </a:solidFill>
+              </a:rPr>
+              <a:t>pandas.pydata.org → API reference → DataFrame</a:t>
+            </a:r>
+            <a:endParaRPr lang="en-US" sz="1600" dirty="0"/>
+          </a:p>
+        </p:txBody>
+      </p:sp>
+      <p:sp>
+        <p:nvSpPr>
+          <p:cNvPr id="18" name="Text 13"/>
+          <p:cNvSpPr txBox="1"/>
+          <p:nvPr/>
+        </p:nvSpPr>
+        <p:spPr>
+          <a:xfrm>
+            <a:off x="548640" y="5257800"/>
+            <a:ext cx="11064240" cy="457200"/>
+          </a:xfrm>
+          <a:prstGeom prst="rect">
+            <a:avLst/>
+          </a:prstGeom>
+          <a:noFill/>
+          <a:ln/>
+        </p:spPr>
+        <p:txBody>
+          <a:bodyPr wrap="square" lIns="0" tIns="0" rIns="0" bIns="0" rtlCol="0" anchor="ctr"/>
+          <a:lstStyle/>
+          <a:p>
+            <a:pPr indent="0" marL="0">
+              <a:buNone/>
+            </a:pPr>
+            <a:r>
+              <a:rPr lang="en-US" sz="1800" i="1" dirty="0">
                 <a:solidFill>
                   <a:srgbClr val="0F4C5C"/>
                 </a:solidFill>
               </a:rPr>
-              <a:t>3</a:t>
-            </a:r>
-            <a:endParaRPr lang="en-US" sz="2080" dirty="0"/>
-          </a:p>
-        </p:txBody>
-      </p:sp>
-      <p:sp>
-        <p:nvSpPr>
-          <p:cNvPr id="16" name="Text 14"/>
-          <p:cNvSpPr txBox="1"/>
-          <p:nvPr/>
-        </p:nvSpPr>
-        <p:spPr>
-          <a:xfrm>
-            <a:off x="1828800" y="3977640"/>
-            <a:ext cx="3931920" cy="502920"/>
-          </a:xfrm>
-          <a:prstGeom prst="rect">
-            <a:avLst/>
-          </a:prstGeom>
-          <a:noFill/>
-          <a:ln/>
-        </p:spPr>
-        <p:txBody>
-          <a:bodyPr wrap="square" lIns="0" tIns="0" rIns="0" bIns="0" rtlCol="0" anchor="ctr"/>
-          <a:lstStyle/>
-          <a:p>
-            <a:pPr indent="0" marL="0">
-              <a:buNone/>
-            </a:pPr>
-            <a:r>
-              <a:rPr lang="en-US" sz="2100" b="1" dirty="0">
-                <a:solidFill>
-                  <a:srgbClr val="1F2A30"/>
-                </a:solidFill>
-              </a:rPr>
-              <a:t>Quanti valori diversi?</a:t>
-            </a:r>
-            <a:endParaRPr lang="en-US" sz="2100" dirty="0"/>
-          </a:p>
-        </p:txBody>
-      </p:sp>
-      <p:sp>
-        <p:nvSpPr>
-          <p:cNvPr id="17" name="Text 15"/>
-          <p:cNvSpPr txBox="1"/>
-          <p:nvPr/>
-        </p:nvSpPr>
-        <p:spPr>
-          <a:xfrm>
-            <a:off x="1828800" y="4526280"/>
-            <a:ext cx="3931920" cy="457200"/>
-          </a:xfrm>
-          <a:prstGeom prst="rect">
-            <a:avLst/>
-          </a:prstGeom>
-          <a:noFill/>
-          <a:ln/>
-        </p:spPr>
-        <p:txBody>
-          <a:bodyPr wrap="square" lIns="0" tIns="0" rIns="0" bIns="0" rtlCol="0" anchor="ctr"/>
-          <a:lstStyle/>
-          <a:p>
-            <a:pPr indent="0" marL="0">
-              <a:buNone/>
-            </a:pPr>
-            <a:r>
-              <a:rPr lang="en-US" sz="1700" dirty="0">
-                <a:solidFill>
-                  <a:srgbClr val="0F4C5C"/>
-                </a:solidFill>
-                <a:latin typeface="Courier New" pitchFamily="34" charset="0"/>
-                <a:ea typeface="Courier New" pitchFamily="34" charset="-122"/>
-                <a:cs typeface="Courier New" pitchFamily="34" charset="-120"/>
-              </a:rPr>
-              <a:t>df["col"].nunique()</a:t>
-            </a:r>
-            <a:endParaRPr lang="en-US" sz="1700" dirty="0"/>
-          </a:p>
-        </p:txBody>
-      </p:sp>
-      <p:sp>
-        <p:nvSpPr>
-          <p:cNvPr id="18" name="Shape 16"/>
-          <p:cNvSpPr/>
-          <p:nvPr/>
-        </p:nvSpPr>
-        <p:spPr>
-          <a:xfrm>
-            <a:off x="6172200" y="3657600"/>
-            <a:ext cx="5440680" cy="1645920"/>
-          </a:xfrm>
-          <a:prstGeom prst="roundRect">
-            <a:avLst>
-              <a:gd name="adj" fmla="val 6667"/>
-            </a:avLst>
-          </a:prstGeom>
-          <a:solidFill>
-            <a:srgbClr val="EEF3F4"/>
-          </a:solidFill>
-          <a:ln/>
-        </p:spPr>
-      </p:sp>
-      <p:sp>
-        <p:nvSpPr>
-          <p:cNvPr id="19" name="Shape 17"/>
-          <p:cNvSpPr/>
-          <p:nvPr/>
-        </p:nvSpPr>
-        <p:spPr>
-          <a:xfrm>
-            <a:off x="6446520" y="4114800"/>
-            <a:ext cx="731520" cy="731520"/>
-          </a:xfrm>
-          <a:prstGeom prst="ellipse">
-            <a:avLst/>
-          </a:prstGeom>
-          <a:solidFill>
-            <a:srgbClr val="FFFFFF"/>
-          </a:solidFill>
-          <a:ln/>
-        </p:spPr>
-      </p:sp>
-      <p:sp>
-        <p:nvSpPr>
-          <p:cNvPr id="20" name="Text 18"/>
-          <p:cNvSpPr txBox="1"/>
-          <p:nvPr/>
-        </p:nvSpPr>
-        <p:spPr>
-          <a:xfrm>
-            <a:off x="6446520" y="4114800"/>
-            <a:ext cx="731520" cy="731520"/>
-          </a:xfrm>
-          <a:prstGeom prst="rect">
-            <a:avLst/>
-          </a:prstGeom>
-          <a:noFill/>
-          <a:ln/>
-        </p:spPr>
-        <p:txBody>
-          <a:bodyPr wrap="square" lIns="0" tIns="0" rIns="0" bIns="0" rtlCol="0" anchor="ctr"/>
-          <a:lstStyle/>
-          <a:p>
-            <a:pPr algn="ctr" indent="0" marL="0">
-              <a:buNone/>
-            </a:pPr>
-            <a:r>
-              <a:rPr lang="en-US" sz="2080" b="1" dirty="0">
-                <a:solidFill>
-                  <a:srgbClr val="0F4C5C"/>
-                </a:solidFill>
-              </a:rPr>
-              <a:t>4</a:t>
-            </a:r>
-            <a:endParaRPr lang="en-US" sz="2080" dirty="0"/>
-          </a:p>
-        </p:txBody>
-      </p:sp>
-      <p:sp>
-        <p:nvSpPr>
-          <p:cNvPr id="21" name="Text 19"/>
-          <p:cNvSpPr txBox="1"/>
-          <p:nvPr/>
-        </p:nvSpPr>
-        <p:spPr>
-          <a:xfrm>
-            <a:off x="7452360" y="3977640"/>
-            <a:ext cx="3931920" cy="502920"/>
-          </a:xfrm>
-          <a:prstGeom prst="rect">
-            <a:avLst/>
-          </a:prstGeom>
-          <a:noFill/>
-          <a:ln/>
-        </p:spPr>
-        <p:txBody>
-          <a:bodyPr wrap="square" lIns="0" tIns="0" rIns="0" bIns="0" rtlCol="0" anchor="ctr"/>
-          <a:lstStyle/>
-          <a:p>
-            <a:pPr indent="0" marL="0">
-              <a:buNone/>
-            </a:pPr>
-            <a:r>
-              <a:rPr lang="en-US" sz="2100" b="1" dirty="0">
-                <a:solidFill>
-                  <a:srgbClr val="1F2A30"/>
-                </a:solidFill>
-              </a:rPr>
-              <a:t>Quali valori, e quante volte?</a:t>
-            </a:r>
-            <a:endParaRPr lang="en-US" sz="2100" dirty="0"/>
-          </a:p>
-        </p:txBody>
-      </p:sp>
-      <p:sp>
-        <p:nvSpPr>
-          <p:cNvPr id="22" name="Text 20"/>
-          <p:cNvSpPr txBox="1"/>
-          <p:nvPr/>
-        </p:nvSpPr>
-        <p:spPr>
-          <a:xfrm>
-            <a:off x="7452360" y="4526280"/>
-            <a:ext cx="3931920" cy="457200"/>
-          </a:xfrm>
-          <a:prstGeom prst="rect">
-            <a:avLst/>
-          </a:prstGeom>
-          <a:noFill/>
-          <a:ln/>
-        </p:spPr>
-        <p:txBody>
-          <a:bodyPr wrap="square" lIns="0" tIns="0" rIns="0" bIns="0" rtlCol="0" anchor="ctr"/>
-          <a:lstStyle/>
-          <a:p>
-            <a:pPr indent="0" marL="0">
-              <a:buNone/>
-            </a:pPr>
-            <a:r>
-              <a:rPr lang="en-US" sz="1700" dirty="0">
-                <a:solidFill>
-                  <a:srgbClr val="0F4C5C"/>
-                </a:solidFill>
-                <a:latin typeface="Courier New" pitchFamily="34" charset="0"/>
-                <a:ea typeface="Courier New" pitchFamily="34" charset="-122"/>
-                <a:cs typeface="Courier New" pitchFamily="34" charset="-120"/>
-              </a:rPr>
-              <a:t>df["col"].value_counts()</a:t>
-            </a:r>
-            <a:endParaRPr lang="en-US" sz="1700" dirty="0"/>
-          </a:p>
-        </p:txBody>
-      </p:sp>
-      <p:sp>
-        <p:nvSpPr>
-          <p:cNvPr id="23" name="Text 21"/>
-          <p:cNvSpPr txBox="1"/>
-          <p:nvPr/>
-        </p:nvSpPr>
-        <p:spPr>
-          <a:xfrm>
-            <a:off x="548640" y="5623560"/>
-            <a:ext cx="11064240" cy="457200"/>
-          </a:xfrm>
-          <a:prstGeom prst="rect">
-            <a:avLst/>
-          </a:prstGeom>
-          <a:noFill/>
-          <a:ln/>
-        </p:spPr>
-        <p:txBody>
-          <a:bodyPr wrap="square" lIns="0" tIns="0" rIns="0" bIns="0" rtlCol="0" anchor="ctr"/>
-          <a:lstStyle/>
-          <a:p>
-            <a:pPr indent="0" marL="0">
-              <a:buNone/>
-            </a:pPr>
-            <a:r>
-              <a:rPr lang="en-US" sz="1800" i="1" dirty="0">
-                <a:solidFill>
-                  <a:srgbClr val="0F4C5C"/>
-                </a:solidFill>
-              </a:rPr>
-              <a:t>Prima di qualunque analisi. Sempre.</a:t>
+              <a:t>Nessuno conosce tutti i metodi. Si cercano, ogni giorno, anche dopo anni.</a:t>
             </a:r>
             <a:endParaRPr lang="en-US" sz="1800" dirty="0"/>
           </a:p>
@@ -3825,83 +3835,724 @@
         </p:nvSpPr>
         <p:spPr>
           <a:xfrm>
-            <a:off x="731520" y="2194560"/>
-            <a:ext cx="10698480" cy="1280160"/>
-          </a:xfrm>
-          <a:prstGeom prst="rect">
-            <a:avLst/>
-          </a:prstGeom>
-          <a:noFill/>
-          <a:ln/>
-        </p:spPr>
-        <p:txBody>
-          <a:bodyPr wrap="square" lIns="0" tIns="0" rIns="0" bIns="0" rtlCol="0" anchor="b"/>
+            <a:off x="548640" y="365760"/>
+            <a:ext cx="11064240" cy="822960"/>
+          </a:xfrm>
+          <a:prstGeom prst="rect">
+            <a:avLst/>
+          </a:prstGeom>
+          <a:noFill/>
+          <a:ln/>
+        </p:spPr>
+        <p:txBody>
+          <a:bodyPr wrap="square" lIns="0" tIns="0" rIns="0" bIns="0" rtlCol="0" anchor="ctr"/>
           <a:lstStyle/>
           <a:p>
             <a:pPr algn="l" indent="0" marL="0">
               <a:buNone/>
             </a:pPr>
             <a:r>
-              <a:rPr lang="en-US" sz="5400" b="1" dirty="0">
-                <a:solidFill>
-                  <a:srgbClr val="FFFFFF"/>
-                </a:solidFill>
-              </a:rPr>
-              <a:t>Task: conosci il tuo dataset</a:t>
-            </a:r>
-            <a:endParaRPr lang="en-US" sz="5400" dirty="0"/>
-          </a:p>
-        </p:txBody>
-      </p:sp>
-      <p:sp>
-        <p:nvSpPr>
-          <p:cNvPr id="3" name="Text 0"/>
+              <a:rPr lang="en-US" sz="3600" b="1" dirty="0">
+                <a:solidFill>
+                  <a:srgbClr val="0F4C5C"/>
+                </a:solidFill>
+              </a:rPr>
+              <a:t>Le domande da fare sempre a un dataset</a:t>
+            </a:r>
+            <a:endParaRPr lang="en-US" sz="3600" dirty="0"/>
+          </a:p>
+        </p:txBody>
+      </p:sp>
+      <p:sp>
+        <p:nvSpPr>
+          <p:cNvPr id="3" name="Shape 1"/>
           <p:cNvSpPr/>
+          <p:nvPr/>
+        </p:nvSpPr>
+        <p:spPr>
+          <a:xfrm>
+            <a:off x="548640" y="1737360"/>
+            <a:ext cx="5440680" cy="1645920"/>
+          </a:xfrm>
+          <a:prstGeom prst="roundRect">
+            <a:avLst>
+              <a:gd name="adj" fmla="val 6667"/>
+            </a:avLst>
+          </a:prstGeom>
+          <a:solidFill>
+            <a:srgbClr val="EEF3F4"/>
+          </a:solidFill>
+          <a:ln/>
+        </p:spPr>
+      </p:sp>
+      <p:sp>
+        <p:nvSpPr>
+          <p:cNvPr id="4" name="Shape 2"/>
+          <p:cNvSpPr/>
+          <p:nvPr/>
+        </p:nvSpPr>
+        <p:spPr>
+          <a:xfrm>
+            <a:off x="822960" y="2194560"/>
+            <a:ext cx="731520" cy="731520"/>
+          </a:xfrm>
+          <a:prstGeom prst="ellipse">
+            <a:avLst/>
+          </a:prstGeom>
+          <a:solidFill>
+            <a:srgbClr val="FFFFFF"/>
+          </a:solidFill>
+          <a:ln/>
+        </p:spPr>
+      </p:sp>
+      <p:sp>
+        <p:nvSpPr>
+          <p:cNvPr id="5" name="Text 3"/>
+          <p:cNvSpPr txBox="1"/>
+          <p:nvPr/>
+        </p:nvSpPr>
+        <p:spPr>
+          <a:xfrm>
+            <a:off x="822960" y="2194560"/>
+            <a:ext cx="731520" cy="731520"/>
+          </a:xfrm>
+          <a:prstGeom prst="rect">
+            <a:avLst/>
+          </a:prstGeom>
+          <a:noFill/>
+          <a:ln/>
+        </p:spPr>
+        <p:txBody>
+          <a:bodyPr wrap="square" lIns="0" tIns="0" rIns="0" bIns="0" rtlCol="0" anchor="ctr"/>
+          <a:lstStyle/>
+          <a:p>
+            <a:pPr algn="ctr" indent="0" marL="0">
+              <a:buNone/>
+            </a:pPr>
+            <a:r>
+              <a:rPr lang="en-US" sz="2080" b="1" dirty="0">
+                <a:solidFill>
+                  <a:srgbClr val="0F4C5C"/>
+                </a:solidFill>
+              </a:rPr>
+              <a:t>1</a:t>
+            </a:r>
+            <a:endParaRPr lang="en-US" sz="2080" dirty="0"/>
+          </a:p>
+        </p:txBody>
+      </p:sp>
+      <p:sp>
+        <p:nvSpPr>
+          <p:cNvPr id="6" name="Text 4"/>
+          <p:cNvSpPr txBox="1"/>
+          <p:nvPr/>
+        </p:nvSpPr>
+        <p:spPr>
+          <a:xfrm>
+            <a:off x="1828800" y="2057400"/>
+            <a:ext cx="3931920" cy="502920"/>
+          </a:xfrm>
+          <a:prstGeom prst="rect">
+            <a:avLst/>
+          </a:prstGeom>
+          <a:noFill/>
+          <a:ln/>
+        </p:spPr>
+        <p:txBody>
+          <a:bodyPr wrap="square" lIns="0" tIns="0" rIns="0" bIns="0" rtlCol="0" anchor="ctr"/>
+          <a:lstStyle/>
+          <a:p>
+            <a:pPr indent="0" marL="0">
+              <a:buNone/>
+            </a:pPr>
+            <a:r>
+              <a:rPr lang="en-US" sz="2100" b="1" dirty="0">
+                <a:solidFill>
+                  <a:srgbClr val="1F2A30"/>
+                </a:solidFill>
+              </a:rPr>
+              <a:t>Quanto è grande?</a:t>
+            </a:r>
+            <a:endParaRPr lang="en-US" sz="2100" dirty="0"/>
+          </a:p>
+        </p:txBody>
+      </p:sp>
+      <p:sp>
+        <p:nvSpPr>
+          <p:cNvPr id="7" name="Text 5"/>
+          <p:cNvSpPr txBox="1"/>
+          <p:nvPr/>
+        </p:nvSpPr>
+        <p:spPr>
+          <a:xfrm>
+            <a:off x="1828800" y="2606040"/>
+            <a:ext cx="3931920" cy="457200"/>
+          </a:xfrm>
+          <a:prstGeom prst="rect">
+            <a:avLst/>
+          </a:prstGeom>
+          <a:noFill/>
+          <a:ln/>
+        </p:spPr>
+        <p:txBody>
+          <a:bodyPr wrap="square" lIns="0" tIns="0" rIns="0" bIns="0" rtlCol="0" anchor="ctr"/>
+          <a:lstStyle/>
+          <a:p>
+            <a:pPr indent="0" marL="0">
+              <a:buNone/>
+            </a:pPr>
+            <a:r>
+              <a:rPr lang="en-US" sz="1700" dirty="0">
+                <a:solidFill>
+                  <a:srgbClr val="0F4C5C"/>
+                </a:solidFill>
+                <a:latin typeface="Courier New" pitchFamily="34" charset="0"/>
+                <a:ea typeface="Courier New" pitchFamily="34" charset="-122"/>
+                <a:cs typeface="Courier New" pitchFamily="34" charset="-120"/>
+              </a:rPr>
+              <a:t>df.shape</a:t>
+            </a:r>
+            <a:endParaRPr lang="en-US" sz="1700" dirty="0"/>
+          </a:p>
+        </p:txBody>
+      </p:sp>
+      <p:sp>
+        <p:nvSpPr>
+          <p:cNvPr id="8" name="Shape 6"/>
+          <p:cNvSpPr/>
+          <p:nvPr/>
+        </p:nvSpPr>
+        <p:spPr>
+          <a:xfrm>
+            <a:off x="6172200" y="1737360"/>
+            <a:ext cx="5440680" cy="1645920"/>
+          </a:xfrm>
+          <a:prstGeom prst="roundRect">
+            <a:avLst>
+              <a:gd name="adj" fmla="val 6667"/>
+            </a:avLst>
+          </a:prstGeom>
+          <a:solidFill>
+            <a:srgbClr val="EEF3F4"/>
+          </a:solidFill>
+          <a:ln/>
+        </p:spPr>
+      </p:sp>
+      <p:sp>
+        <p:nvSpPr>
+          <p:cNvPr id="9" name="Shape 7"/>
+          <p:cNvSpPr/>
+          <p:nvPr/>
+        </p:nvSpPr>
+        <p:spPr>
+          <a:xfrm>
+            <a:off x="6446520" y="2194560"/>
+            <a:ext cx="731520" cy="731520"/>
+          </a:xfrm>
+          <a:prstGeom prst="ellipse">
+            <a:avLst/>
+          </a:prstGeom>
+          <a:solidFill>
+            <a:srgbClr val="FFFFFF"/>
+          </a:solidFill>
+          <a:ln/>
+        </p:spPr>
+      </p:sp>
+      <p:sp>
+        <p:nvSpPr>
+          <p:cNvPr id="10" name="Text 8"/>
+          <p:cNvSpPr txBox="1"/>
+          <p:nvPr/>
+        </p:nvSpPr>
+        <p:spPr>
+          <a:xfrm>
+            <a:off x="6446520" y="2194560"/>
+            <a:ext cx="731520" cy="731520"/>
+          </a:xfrm>
+          <a:prstGeom prst="rect">
+            <a:avLst/>
+          </a:prstGeom>
+          <a:noFill/>
+          <a:ln/>
+        </p:spPr>
+        <p:txBody>
+          <a:bodyPr wrap="square" lIns="0" tIns="0" rIns="0" bIns="0" rtlCol="0" anchor="ctr"/>
+          <a:lstStyle/>
+          <a:p>
+            <a:pPr algn="ctr" indent="0" marL="0">
+              <a:buNone/>
+            </a:pPr>
+            <a:r>
+              <a:rPr lang="en-US" sz="2080" b="1" dirty="0">
+                <a:solidFill>
+                  <a:srgbClr val="0F4C5C"/>
+                </a:solidFill>
+              </a:rPr>
+              <a:t>2</a:t>
+            </a:r>
+            <a:endParaRPr lang="en-US" sz="2080" dirty="0"/>
+          </a:p>
+        </p:txBody>
+      </p:sp>
+      <p:sp>
+        <p:nvSpPr>
+          <p:cNvPr id="11" name="Text 9"/>
+          <p:cNvSpPr txBox="1"/>
+          <p:nvPr/>
+        </p:nvSpPr>
+        <p:spPr>
+          <a:xfrm>
+            <a:off x="7452360" y="2057400"/>
+            <a:ext cx="3931920" cy="502920"/>
+          </a:xfrm>
+          <a:prstGeom prst="rect">
+            <a:avLst/>
+          </a:prstGeom>
+          <a:noFill/>
+          <a:ln/>
+        </p:spPr>
+        <p:txBody>
+          <a:bodyPr wrap="square" lIns="0" tIns="0" rIns="0" bIns="0" rtlCol="0" anchor="ctr"/>
+          <a:lstStyle/>
+          <a:p>
+            <a:pPr indent="0" marL="0">
+              <a:buNone/>
+            </a:pPr>
+            <a:r>
+              <a:rPr lang="en-US" sz="2100" b="1" dirty="0">
+                <a:solidFill>
+                  <a:srgbClr val="1F2A30"/>
+                </a:solidFill>
+              </a:rPr>
+              <a:t>Di che tipo sono le colonne?</a:t>
+            </a:r>
+            <a:endParaRPr lang="en-US" sz="2100" dirty="0"/>
+          </a:p>
+        </p:txBody>
+      </p:sp>
+      <p:sp>
+        <p:nvSpPr>
+          <p:cNvPr id="12" name="Text 10"/>
+          <p:cNvSpPr txBox="1"/>
+          <p:nvPr/>
+        </p:nvSpPr>
+        <p:spPr>
+          <a:xfrm>
+            <a:off x="7452360" y="2606040"/>
+            <a:ext cx="3931920" cy="457200"/>
+          </a:xfrm>
+          <a:prstGeom prst="rect">
+            <a:avLst/>
+          </a:prstGeom>
+          <a:noFill/>
+          <a:ln/>
+        </p:spPr>
+        <p:txBody>
+          <a:bodyPr wrap="square" lIns="0" tIns="0" rIns="0" bIns="0" rtlCol="0" anchor="ctr"/>
+          <a:lstStyle/>
+          <a:p>
+            <a:pPr indent="0" marL="0">
+              <a:buNone/>
+            </a:pPr>
+            <a:r>
+              <a:rPr lang="en-US" sz="1700" dirty="0">
+                <a:solidFill>
+                  <a:srgbClr val="0F4C5C"/>
+                </a:solidFill>
+                <a:latin typeface="Courier New" pitchFamily="34" charset="0"/>
+                <a:ea typeface="Courier New" pitchFamily="34" charset="-122"/>
+                <a:cs typeface="Courier New" pitchFamily="34" charset="-120"/>
+              </a:rPr>
+              <a:t>df.dtypes</a:t>
+            </a:r>
+            <a:endParaRPr lang="en-US" sz="1700" dirty="0"/>
+          </a:p>
+        </p:txBody>
+      </p:sp>
+      <p:sp>
+        <p:nvSpPr>
+          <p:cNvPr id="13" name="Shape 11"/>
+          <p:cNvSpPr/>
+          <p:nvPr/>
+        </p:nvSpPr>
+        <p:spPr>
+          <a:xfrm>
+            <a:off x="548640" y="3657600"/>
+            <a:ext cx="5440680" cy="1645920"/>
+          </a:xfrm>
+          <a:prstGeom prst="roundRect">
+            <a:avLst>
+              <a:gd name="adj" fmla="val 6667"/>
+            </a:avLst>
+          </a:prstGeom>
+          <a:solidFill>
+            <a:srgbClr val="EEF3F4"/>
+          </a:solidFill>
+          <a:ln/>
+        </p:spPr>
+      </p:sp>
+      <p:sp>
+        <p:nvSpPr>
+          <p:cNvPr id="14" name="Shape 12"/>
+          <p:cNvSpPr/>
+          <p:nvPr/>
+        </p:nvSpPr>
+        <p:spPr>
+          <a:xfrm>
+            <a:off x="822960" y="4114800"/>
+            <a:ext cx="731520" cy="731520"/>
+          </a:xfrm>
+          <a:prstGeom prst="ellipse">
+            <a:avLst/>
+          </a:prstGeom>
+          <a:solidFill>
+            <a:srgbClr val="FFFFFF"/>
+          </a:solidFill>
+          <a:ln/>
+        </p:spPr>
+      </p:sp>
+      <p:sp>
+        <p:nvSpPr>
+          <p:cNvPr id="15" name="Text 13"/>
+          <p:cNvSpPr txBox="1"/>
+          <p:nvPr/>
+        </p:nvSpPr>
+        <p:spPr>
+          <a:xfrm>
+            <a:off x="822960" y="4114800"/>
+            <a:ext cx="731520" cy="731520"/>
+          </a:xfrm>
+          <a:prstGeom prst="rect">
+            <a:avLst/>
+          </a:prstGeom>
+          <a:noFill/>
+          <a:ln/>
+        </p:spPr>
+        <p:txBody>
+          <a:bodyPr wrap="square" lIns="0" tIns="0" rIns="0" bIns="0" rtlCol="0" anchor="ctr"/>
+          <a:lstStyle/>
+          <a:p>
+            <a:pPr algn="ctr" indent="0" marL="0">
+              <a:buNone/>
+            </a:pPr>
+            <a:r>
+              <a:rPr lang="en-US" sz="2080" b="1" dirty="0">
+                <a:solidFill>
+                  <a:srgbClr val="0F4C5C"/>
+                </a:solidFill>
+              </a:rPr>
+              <a:t>3</a:t>
+            </a:r>
+            <a:endParaRPr lang="en-US" sz="2080" dirty="0"/>
+          </a:p>
+        </p:txBody>
+      </p:sp>
+      <p:sp>
+        <p:nvSpPr>
+          <p:cNvPr id="16" name="Text 14"/>
+          <p:cNvSpPr txBox="1"/>
+          <p:nvPr/>
+        </p:nvSpPr>
+        <p:spPr>
+          <a:xfrm>
+            <a:off x="1828800" y="3977640"/>
+            <a:ext cx="3931920" cy="502920"/>
+          </a:xfrm>
+          <a:prstGeom prst="rect">
+            <a:avLst/>
+          </a:prstGeom>
+          <a:noFill/>
+          <a:ln/>
+        </p:spPr>
+        <p:txBody>
+          <a:bodyPr wrap="square" lIns="0" tIns="0" rIns="0" bIns="0" rtlCol="0" anchor="ctr"/>
+          <a:lstStyle/>
+          <a:p>
+            <a:pPr indent="0" marL="0">
+              <a:buNone/>
+            </a:pPr>
+            <a:r>
+              <a:rPr lang="en-US" sz="2100" b="1" dirty="0">
+                <a:solidFill>
+                  <a:srgbClr val="1F2A30"/>
+                </a:solidFill>
+              </a:rPr>
+              <a:t>Quanti valori diversi?</a:t>
+            </a:r>
+            <a:endParaRPr lang="en-US" sz="2100" dirty="0"/>
+          </a:p>
+        </p:txBody>
+      </p:sp>
+      <p:sp>
+        <p:nvSpPr>
+          <p:cNvPr id="17" name="Text 15"/>
+          <p:cNvSpPr txBox="1"/>
+          <p:nvPr/>
+        </p:nvSpPr>
+        <p:spPr>
+          <a:xfrm>
+            <a:off x="1828800" y="4526280"/>
+            <a:ext cx="3931920" cy="457200"/>
+          </a:xfrm>
+          <a:prstGeom prst="rect">
+            <a:avLst/>
+          </a:prstGeom>
+          <a:noFill/>
+          <a:ln/>
+        </p:spPr>
+        <p:txBody>
+          <a:bodyPr wrap="square" lIns="0" tIns="0" rIns="0" bIns="0" rtlCol="0" anchor="ctr"/>
+          <a:lstStyle/>
+          <a:p>
+            <a:pPr indent="0" marL="0">
+              <a:buNone/>
+            </a:pPr>
+            <a:r>
+              <a:rPr lang="en-US" sz="1700" dirty="0">
+                <a:solidFill>
+                  <a:srgbClr val="0F4C5C"/>
+                </a:solidFill>
+                <a:latin typeface="Courier New" pitchFamily="34" charset="0"/>
+                <a:ea typeface="Courier New" pitchFamily="34" charset="-122"/>
+                <a:cs typeface="Courier New" pitchFamily="34" charset="-120"/>
+              </a:rPr>
+              <a:t>df["col"].nunique()</a:t>
+            </a:r>
+            <a:endParaRPr lang="en-US" sz="1700" dirty="0"/>
+          </a:p>
+        </p:txBody>
+      </p:sp>
+      <p:sp>
+        <p:nvSpPr>
+          <p:cNvPr id="18" name="Shape 16"/>
+          <p:cNvSpPr/>
+          <p:nvPr/>
+        </p:nvSpPr>
+        <p:spPr>
+          <a:xfrm>
+            <a:off x="6172200" y="3657600"/>
+            <a:ext cx="5440680" cy="1645920"/>
+          </a:xfrm>
+          <a:prstGeom prst="roundRect">
+            <a:avLst>
+              <a:gd name="adj" fmla="val 6667"/>
+            </a:avLst>
+          </a:prstGeom>
+          <a:solidFill>
+            <a:srgbClr val="EEF3F4"/>
+          </a:solidFill>
+          <a:ln/>
+        </p:spPr>
+      </p:sp>
+      <p:sp>
+        <p:nvSpPr>
+          <p:cNvPr id="19" name="Shape 17"/>
+          <p:cNvSpPr/>
+          <p:nvPr/>
+        </p:nvSpPr>
+        <p:spPr>
+          <a:xfrm>
+            <a:off x="6446520" y="4114800"/>
+            <a:ext cx="731520" cy="731520"/>
+          </a:xfrm>
+          <a:prstGeom prst="ellipse">
+            <a:avLst/>
+          </a:prstGeom>
+          <a:solidFill>
+            <a:srgbClr val="FFFFFF"/>
+          </a:solidFill>
+          <a:ln/>
+        </p:spPr>
+      </p:sp>
+      <p:sp>
+        <p:nvSpPr>
+          <p:cNvPr id="20" name="Text 18"/>
+          <p:cNvSpPr txBox="1"/>
+          <p:nvPr/>
+        </p:nvSpPr>
+        <p:spPr>
+          <a:xfrm>
+            <a:off x="6446520" y="4114800"/>
+            <a:ext cx="731520" cy="731520"/>
+          </a:xfrm>
+          <a:prstGeom prst="rect">
+            <a:avLst/>
+          </a:prstGeom>
+          <a:noFill/>
+          <a:ln/>
+        </p:spPr>
+        <p:txBody>
+          <a:bodyPr wrap="square" lIns="0" tIns="0" rIns="0" bIns="0" rtlCol="0" anchor="ctr"/>
+          <a:lstStyle/>
+          <a:p>
+            <a:pPr algn="ctr" indent="0" marL="0">
+              <a:buNone/>
+            </a:pPr>
+            <a:r>
+              <a:rPr lang="en-US" sz="2080" b="1" dirty="0">
+                <a:solidFill>
+                  <a:srgbClr val="0F4C5C"/>
+                </a:solidFill>
+              </a:rPr>
+              <a:t>4</a:t>
+            </a:r>
+            <a:endParaRPr lang="en-US" sz="2080" dirty="0"/>
+          </a:p>
+        </p:txBody>
+      </p:sp>
+      <p:sp>
+        <p:nvSpPr>
+          <p:cNvPr id="21" name="Text 19"/>
+          <p:cNvSpPr txBox="1"/>
+          <p:nvPr/>
+        </p:nvSpPr>
+        <p:spPr>
+          <a:xfrm>
+            <a:off x="7452360" y="3977640"/>
+            <a:ext cx="3931920" cy="502920"/>
+          </a:xfrm>
+          <a:prstGeom prst="rect">
+            <a:avLst/>
+          </a:prstGeom>
+          <a:noFill/>
+          <a:ln/>
+        </p:spPr>
+        <p:txBody>
+          <a:bodyPr wrap="square" lIns="0" tIns="0" rIns="0" bIns="0" rtlCol="0" anchor="ctr"/>
+          <a:lstStyle/>
+          <a:p>
+            <a:pPr indent="0" marL="0">
+              <a:buNone/>
+            </a:pPr>
+            <a:r>
+              <a:rPr lang="en-US" sz="2100" b="1" dirty="0">
+                <a:solidFill>
+                  <a:srgbClr val="1F2A30"/>
+                </a:solidFill>
+              </a:rPr>
+              <a:t>Quali valori, e quante volte?</a:t>
+            </a:r>
+            <a:endParaRPr lang="en-US" sz="2100" dirty="0"/>
+          </a:p>
+        </p:txBody>
+      </p:sp>
+      <p:sp>
+        <p:nvSpPr>
+          <p:cNvPr id="22" name="Text 20"/>
+          <p:cNvSpPr txBox="1"/>
+          <p:nvPr/>
+        </p:nvSpPr>
+        <p:spPr>
+          <a:xfrm>
+            <a:off x="7452360" y="4526280"/>
+            <a:ext cx="3931920" cy="457200"/>
+          </a:xfrm>
+          <a:prstGeom prst="rect">
+            <a:avLst/>
+          </a:prstGeom>
+          <a:noFill/>
+          <a:ln/>
+        </p:spPr>
+        <p:txBody>
+          <a:bodyPr wrap="square" lIns="0" tIns="0" rIns="0" bIns="0" rtlCol="0" anchor="ctr"/>
+          <a:lstStyle/>
+          <a:p>
+            <a:pPr indent="0" marL="0">
+              <a:buNone/>
+            </a:pPr>
+            <a:r>
+              <a:rPr lang="en-US" sz="1700" dirty="0">
+                <a:solidFill>
+                  <a:srgbClr val="0F4C5C"/>
+                </a:solidFill>
+                <a:latin typeface="Courier New" pitchFamily="34" charset="0"/>
+                <a:ea typeface="Courier New" pitchFamily="34" charset="-122"/>
+                <a:cs typeface="Courier New" pitchFamily="34" charset="-120"/>
+              </a:rPr>
+              <a:t>df["col"].value_counts()</a:t>
+            </a:r>
+            <a:endParaRPr lang="en-US" sz="1700" dirty="0"/>
+          </a:p>
+        </p:txBody>
+      </p:sp>
+      <p:sp>
+        <p:nvSpPr>
+          <p:cNvPr id="23" name="Text 21"/>
+          <p:cNvSpPr txBox="1"/>
+          <p:nvPr/>
+        </p:nvSpPr>
+        <p:spPr>
+          <a:xfrm>
+            <a:off x="548640" y="5623560"/>
+            <a:ext cx="11064240" cy="457200"/>
+          </a:xfrm>
+          <a:prstGeom prst="rect">
+            <a:avLst/>
+          </a:prstGeom>
+          <a:noFill/>
+          <a:ln/>
+        </p:spPr>
+        <p:txBody>
+          <a:bodyPr wrap="square" lIns="0" tIns="0" rIns="0" bIns="0" rtlCol="0" anchor="ctr"/>
+          <a:lstStyle/>
+          <a:p>
+            <a:pPr indent="0" marL="0">
+              <a:buNone/>
+            </a:pPr>
+            <a:r>
+              <a:rPr lang="en-US" sz="1800" i="1" dirty="0">
+                <a:solidFill>
+                  <a:srgbClr val="0F4C5C"/>
+                </a:solidFill>
+              </a:rPr>
+              <a:t>Prima di qualunque analisi. Sempre.</a:t>
+            </a:r>
+            <a:endParaRPr lang="en-US" sz="1800" dirty="0"/>
+          </a:p>
+        </p:txBody>
+      </p:sp>
+      <p:sp>
+        <p:nvSpPr>
+          <p:cNvPr id="25" name="Slide Number Placeholder 0"/>
+          <p:cNvSpPr>
+            <a:spLocks noGrp="1"/>
+          </p:cNvSpPr>
           <p:nvPr>
-            <p:ph idx="101" type="body" hasCustomPrompt="1"/>
+            <p:ph type="sldNum" sz="quarter" idx="4294967295"/>
           </p:nvPr>
         </p:nvSpPr>
         <p:spPr>
           <a:xfrm>
-            <a:off x="731520" y="3657600"/>
-            <a:ext cx="10698480" cy="1463040"/>
-          </a:xfrm>
-          <a:prstGeom prst="rect">
-            <a:avLst/>
-          </a:prstGeom>
-          <a:noFill/>
-          <a:ln/>
-        </p:spPr>
-        <p:txBody>
-          <a:bodyPr wrap="square" lIns="0" tIns="0" rIns="0" bIns="0" rtlCol="0" anchor="t"/>
-          <a:lstStyle/>
-          <a:p>
-            <a:pPr indent="0" marL="0">
-              <a:buNone/>
-            </a:pPr>
-            <a:r>
-              <a:rPr lang="en-US" sz="2200" dirty="0">
-                <a:solidFill>
-                  <a:srgbClr val="B8C4CB"/>
-                </a:solidFill>
-              </a:rPr>
-              <a:t>Un collega ti manda imprese.xlsx. Ti puoi fidare?</a:t>
-            </a:r>
-            <a:endParaRPr lang="en-US" sz="2200" dirty="0"/>
-          </a:p>
-          <a:p>
-            <a:pPr indent="0" marL="0">
-              <a:buNone/>
-            </a:pPr>
-            <a:r>
-              <a:rPr lang="en-US" sz="2200" dirty="0">
-                <a:solidFill>
-                  <a:srgbClr val="B8C4CB"/>
-                </a:solidFill>
-              </a:rPr>
-              <a:t>60 minuti · apri il notebook dal README</a:t>
-            </a:r>
-            <a:endParaRPr lang="en-US" sz="2200" dirty="0"/>
+            <a:off x="11155680" y="6400800"/>
+            <a:ext cx="457200" cy="274320"/>
+          </a:xfrm>
+          <a:prstGeom prst="rect">
+            <a:avLst/>
+          </a:prstGeom>
+          <a:extLst>
+            <a:ext uri="{C572A759-6A51-4108-AA02-DFA0A04FC94B}">
+              <ma14:wrappingTextBoxFlag xmlns:ma14="http://schemas.microsoft.com/office/mac/drawingml/2011/main" val="0"/>
+            </a:ext>
+          </a:extLst>
+        </p:spPr>
+        <p:txBody>
+          <a:bodyPr/>
+          <a:lstStyle>
+            <a:lvl1pPr>
+              <a:defRPr sz="1000">
+                <a:solidFill>
+                  <a:srgbClr val="5C6F7B"/>
+                </a:solidFill>
+              </a:defRPr>
+            </a:lvl1pPr>
+          </a:lstStyle>
+          <a:p>
+            <a:pPr algn="r"/>
+            <a:fld id="{F7021451-1387-4CA6-816F-3879F97B5CBC}" type="slidenum">
+              <a:rPr b="0" lang="en-US"/>
+              <a:t>12</a:t>
+            </a:fld>
+            <a:endParaRPr lang="en-US"/>
           </a:p>
         </p:txBody>
       </p:sp>
@@ -3916,6 +4567,121 @@
 <file path=ppt/slides/slide13.xml><?xml version="1.0" encoding="utf-8"?>
 <p:sld xmlns:a="http://schemas.openxmlformats.org/drawingml/2006/main" xmlns:r="http://schemas.openxmlformats.org/officeDocument/2006/relationships" xmlns:p="http://schemas.openxmlformats.org/presentationml/2006/main">
   <p:cSld name="Slide 13">
+    <p:spTree>
+      <p:nvGrpSpPr>
+        <p:cNvPr id="1" name=""/>
+        <p:cNvGrpSpPr/>
+        <p:nvPr/>
+      </p:nvGrpSpPr>
+      <p:grpSpPr>
+        <a:xfrm>
+          <a:off x="0" y="0"/>
+          <a:ext cx="0" cy="0"/>
+          <a:chOff x="0" y="0"/>
+          <a:chExt cx="0" cy="0"/>
+        </a:xfrm>
+      </p:grpSpPr>
+      <p:sp>
+        <p:nvSpPr>
+          <p:cNvPr id="2" name="Text 0"/>
+          <p:cNvSpPr/>
+          <p:nvPr>
+            <p:ph idx="100" type="title" hasCustomPrompt="1"/>
+          </p:nvPr>
+        </p:nvSpPr>
+        <p:spPr>
+          <a:xfrm>
+            <a:off x="731520" y="2194560"/>
+            <a:ext cx="10698480" cy="1280160"/>
+          </a:xfrm>
+          <a:prstGeom prst="rect">
+            <a:avLst/>
+          </a:prstGeom>
+          <a:noFill/>
+          <a:ln/>
+        </p:spPr>
+        <p:txBody>
+          <a:bodyPr wrap="square" lIns="0" tIns="0" rIns="0" bIns="0" rtlCol="0" anchor="b"/>
+          <a:lstStyle/>
+          <a:p>
+            <a:pPr algn="l" indent="0" marL="0">
+              <a:buNone/>
+            </a:pPr>
+            <a:r>
+              <a:rPr lang="en-US" sz="5400" b="1" dirty="0">
+                <a:solidFill>
+                  <a:srgbClr val="FFFFFF"/>
+                </a:solidFill>
+              </a:rPr>
+              <a:t>Task: conosci il tuo dataset</a:t>
+            </a:r>
+            <a:endParaRPr lang="en-US" sz="5400" dirty="0"/>
+          </a:p>
+        </p:txBody>
+      </p:sp>
+      <p:sp>
+        <p:nvSpPr>
+          <p:cNvPr id="3" name="Text 0"/>
+          <p:cNvSpPr/>
+          <p:nvPr>
+            <p:ph idx="101" type="body" hasCustomPrompt="1"/>
+          </p:nvPr>
+        </p:nvSpPr>
+        <p:spPr>
+          <a:xfrm>
+            <a:off x="731520" y="3657600"/>
+            <a:ext cx="10698480" cy="1463040"/>
+          </a:xfrm>
+          <a:prstGeom prst="rect">
+            <a:avLst/>
+          </a:prstGeom>
+          <a:noFill/>
+          <a:ln/>
+        </p:spPr>
+        <p:txBody>
+          <a:bodyPr wrap="square" lIns="0" tIns="0" rIns="0" bIns="0" rtlCol="0" anchor="t"/>
+          <a:lstStyle/>
+          <a:p>
+            <a:pPr indent="0" marL="0">
+              <a:buNone/>
+            </a:pPr>
+            <a:r>
+              <a:rPr lang="en-US" sz="2200" dirty="0">
+                <a:solidFill>
+                  <a:srgbClr val="B8C4CB"/>
+                </a:solidFill>
+              </a:rPr>
+              <a:t>Un collega ti manda imprese.xlsx. Ti puoi fidare?</a:t>
+            </a:r>
+            <a:endParaRPr lang="en-US" sz="2200" dirty="0"/>
+          </a:p>
+          <a:p>
+            <a:pPr indent="0" marL="0">
+              <a:buNone/>
+            </a:pPr>
+            <a:r>
+              <a:rPr lang="en-US" sz="2200" dirty="0">
+                <a:solidFill>
+                  <a:srgbClr val="B8C4CB"/>
+                </a:solidFill>
+              </a:rPr>
+              <a:t>60 minuti · apri il notebook dal README</a:t>
+            </a:r>
+            <a:endParaRPr lang="en-US" sz="2200" dirty="0"/>
+          </a:p>
+        </p:txBody>
+      </p:sp>
+    </p:spTree>
+  </p:cSld>
+  <p:clrMapOvr>
+    <a:masterClrMapping/>
+  </p:clrMapOvr>
+</p:sld>
+</file>
+
+<file path=ppt/slides/slide14.xml><?xml version="1.0" encoding="utf-8"?>
+<p:sld xmlns:a="http://schemas.openxmlformats.org/drawingml/2006/main" xmlns:r="http://schemas.openxmlformats.org/officeDocument/2006/relationships" xmlns:p="http://schemas.openxmlformats.org/presentationml/2006/main">
+  <p:cSld name="Slide 14">
     <p:spTree>
       <p:nvGrpSpPr>
         <p:cNvPr id="1" name=""/>
@@ -9834,6 +10600,998 @@
                   <a:srgbClr val="0F4C5C"/>
                 </a:solidFill>
               </a:rPr>
+              <a:t>Omissioni e passo</a:t>
+            </a:r>
+            <a:endParaRPr lang="en-US" sz="3600" dirty="0"/>
+          </a:p>
+        </p:txBody>
+      </p:sp>
+      <p:sp>
+        <p:nvSpPr>
+          <p:cNvPr id="3" name="Text 1"/>
+          <p:cNvSpPr txBox="1"/>
+          <p:nvPr/>
+        </p:nvSpPr>
+        <p:spPr>
+          <a:xfrm>
+            <a:off x="548640" y="1600200"/>
+            <a:ext cx="5394960" cy="457200"/>
+          </a:xfrm>
+          <a:prstGeom prst="rect">
+            <a:avLst/>
+          </a:prstGeom>
+          <a:noFill/>
+          <a:ln/>
+        </p:spPr>
+        <p:txBody>
+          <a:bodyPr wrap="square" lIns="0" tIns="0" rIns="0" bIns="0" rtlCol="0" anchor="ctr"/>
+          <a:lstStyle/>
+          <a:p>
+            <a:pPr indent="0" marL="0">
+              <a:buNone/>
+            </a:pPr>
+            <a:r>
+              <a:rPr lang="en-US" sz="2400" b="1" dirty="0">
+                <a:solidFill>
+                  <a:srgbClr val="0F4C5C"/>
+                </a:solidFill>
+              </a:rPr>
+              <a:t>Omettere inizio o fine</a:t>
+            </a:r>
+            <a:endParaRPr lang="en-US" sz="2400" dirty="0"/>
+          </a:p>
+        </p:txBody>
+      </p:sp>
+      <p:sp>
+        <p:nvSpPr>
+          <p:cNvPr id="4" name="Text 2"/>
+          <p:cNvSpPr txBox="1"/>
+          <p:nvPr/>
+        </p:nvSpPr>
+        <p:spPr>
+          <a:xfrm>
+            <a:off x="6217920" y="1600200"/>
+            <a:ext cx="5394960" cy="457200"/>
+          </a:xfrm>
+          <a:prstGeom prst="rect">
+            <a:avLst/>
+          </a:prstGeom>
+          <a:noFill/>
+          <a:ln/>
+        </p:spPr>
+        <p:txBody>
+          <a:bodyPr wrap="square" lIns="0" tIns="0" rIns="0" bIns="0" rtlCol="0" anchor="ctr"/>
+          <a:lstStyle/>
+          <a:p>
+            <a:pPr indent="0" marL="0">
+              <a:buNone/>
+            </a:pPr>
+            <a:r>
+              <a:rPr lang="en-US" sz="2400" b="1" dirty="0">
+                <a:solidFill>
+                  <a:srgbClr val="0F4C5C"/>
+                </a:solidFill>
+              </a:rPr>
+              <a:t>Il terzo numero: il passo</a:t>
+            </a:r>
+            <a:endParaRPr lang="en-US" sz="2400" dirty="0"/>
+          </a:p>
+        </p:txBody>
+      </p:sp>
+      <p:sp>
+        <p:nvSpPr>
+          <p:cNvPr id="5" name="Text 3"/>
+          <p:cNvSpPr txBox="1"/>
+          <p:nvPr/>
+        </p:nvSpPr>
+        <p:spPr>
+          <a:xfrm>
+            <a:off x="548640" y="2057400"/>
+            <a:ext cx="5394960" cy="548640"/>
+          </a:xfrm>
+          <a:prstGeom prst="rect">
+            <a:avLst/>
+          </a:prstGeom>
+          <a:noFill/>
+          <a:ln/>
+        </p:spPr>
+        <p:txBody>
+          <a:bodyPr wrap="square" lIns="0" tIns="0" rIns="0" bIns="0" rtlCol="0" anchor="ctr"/>
+          <a:lstStyle/>
+          <a:p>
+            <a:pPr indent="0" marL="0">
+              <a:buNone/>
+            </a:pPr>
+            <a:r>
+              <a:rPr lang="en-US" sz="1500" dirty="0">
+                <a:solidFill>
+                  <a:srgbClr val="5C6F7B"/>
+                </a:solidFill>
+              </a:rPr>
+              <a:t>Se manca l'inizio si parte da 0; se manca la fine si arriva in fondo.</a:t>
+            </a:r>
+            <a:endParaRPr lang="en-US" sz="1500" dirty="0"/>
+          </a:p>
+        </p:txBody>
+      </p:sp>
+      <p:sp>
+        <p:nvSpPr>
+          <p:cNvPr id="6" name="Text 4"/>
+          <p:cNvSpPr txBox="1"/>
+          <p:nvPr/>
+        </p:nvSpPr>
+        <p:spPr>
+          <a:xfrm>
+            <a:off x="6217920" y="2057400"/>
+            <a:ext cx="5394960" cy="548640"/>
+          </a:xfrm>
+          <a:prstGeom prst="rect">
+            <a:avLst/>
+          </a:prstGeom>
+          <a:noFill/>
+          <a:ln/>
+        </p:spPr>
+        <p:txBody>
+          <a:bodyPr wrap="square" lIns="0" tIns="0" rIns="0" bIns="0" rtlCol="0" anchor="ctr"/>
+          <a:lstStyle/>
+          <a:p>
+            <a:pPr indent="0" marL="0">
+              <a:buNone/>
+            </a:pPr>
+            <a:r>
+              <a:rPr lang="en-US" sz="1500" dirty="0">
+                <a:solidFill>
+                  <a:srgbClr val="5C6F7B"/>
+                </a:solidFill>
+              </a:rPr>
+              <a:t>[inizio:fine:passo]  —  ogni quante caselle prenderne una</a:t>
+            </a:r>
+            <a:endParaRPr lang="en-US" sz="1500" dirty="0"/>
+          </a:p>
+        </p:txBody>
+      </p:sp>
+      <p:sp>
+        <p:nvSpPr>
+          <p:cNvPr id="7" name="Shape 5"/>
+          <p:cNvSpPr/>
+          <p:nvPr/>
+        </p:nvSpPr>
+        <p:spPr>
+          <a:xfrm>
+            <a:off x="548640" y="2743200"/>
+            <a:ext cx="5394960" cy="713232"/>
+          </a:xfrm>
+          <a:prstGeom prst="roundRect">
+            <a:avLst>
+              <a:gd name="adj" fmla="val 12821"/>
+            </a:avLst>
+          </a:prstGeom>
+          <a:solidFill>
+            <a:srgbClr val="EEF3F4"/>
+          </a:solidFill>
+          <a:ln/>
+        </p:spPr>
+      </p:sp>
+      <p:sp>
+        <p:nvSpPr>
+          <p:cNvPr id="8" name="Text 6"/>
+          <p:cNvSpPr txBox="1"/>
+          <p:nvPr/>
+        </p:nvSpPr>
+        <p:spPr>
+          <a:xfrm>
+            <a:off x="777240" y="2743200"/>
+            <a:ext cx="3291840" cy="713232"/>
+          </a:xfrm>
+          <a:prstGeom prst="rect">
+            <a:avLst/>
+          </a:prstGeom>
+          <a:noFill/>
+          <a:ln/>
+        </p:spPr>
+        <p:txBody>
+          <a:bodyPr wrap="square" lIns="0" tIns="0" rIns="0" bIns="0" rtlCol="0" anchor="ctr"/>
+          <a:lstStyle/>
+          <a:p>
+            <a:pPr indent="0" marL="0">
+              <a:buNone/>
+            </a:pPr>
+            <a:r>
+              <a:rPr lang="en-US" sz="1800" b="1" dirty="0">
+                <a:solidFill>
+                  <a:srgbClr val="0F4C5C"/>
+                </a:solidFill>
+                <a:latin typeface="Courier New" pitchFamily="34" charset="0"/>
+                <a:ea typeface="Courier New" pitchFamily="34" charset="-122"/>
+                <a:cs typeface="Courier New" pitchFamily="34" charset="-120"/>
+              </a:rPr>
+              <a:t>x[:3] </a:t>
+            </a:r>
+            <a:pPr indent="0" marL="0">
+              <a:buNone/>
+            </a:pPr>
+            <a:r>
+              <a:rPr lang="en-US" sz="1800" dirty="0">
+                <a:solidFill>
+                  <a:srgbClr val="5C6F7B"/>
+                </a:solidFill>
+                <a:latin typeface="Courier New" pitchFamily="34" charset="0"/>
+                <a:ea typeface="Courier New" pitchFamily="34" charset="-122"/>
+                <a:cs typeface="Courier New" pitchFamily="34" charset="-120"/>
+              </a:rPr>
+              <a:t>  = x[0:3]</a:t>
+            </a:r>
+            <a:endParaRPr lang="en-US" sz="1800" dirty="0"/>
+          </a:p>
+        </p:txBody>
+      </p:sp>
+      <p:sp>
+        <p:nvSpPr>
+          <p:cNvPr id="9" name="Text 7"/>
+          <p:cNvSpPr txBox="1"/>
+          <p:nvPr/>
+        </p:nvSpPr>
+        <p:spPr>
+          <a:xfrm>
+            <a:off x="4114800" y="2743200"/>
+            <a:ext cx="1691640" cy="713232"/>
+          </a:xfrm>
+          <a:prstGeom prst="rect">
+            <a:avLst/>
+          </a:prstGeom>
+          <a:noFill/>
+          <a:ln/>
+        </p:spPr>
+        <p:txBody>
+          <a:bodyPr wrap="square" lIns="0" tIns="0" rIns="0" bIns="0" rtlCol="0" anchor="ctr"/>
+          <a:lstStyle/>
+          <a:p>
+            <a:pPr indent="0" marL="0">
+              <a:buNone/>
+            </a:pPr>
+            <a:r>
+              <a:rPr lang="en-US" sz="1800" dirty="0">
+                <a:solidFill>
+                  <a:srgbClr val="1F2A30"/>
+                </a:solidFill>
+                <a:latin typeface="Courier New" pitchFamily="34" charset="0"/>
+                <a:ea typeface="Courier New" pitchFamily="34" charset="-122"/>
+                <a:cs typeface="Courier New" pitchFamily="34" charset="-120"/>
+              </a:rPr>
+              <a:t>A B C</a:t>
+            </a:r>
+            <a:endParaRPr lang="en-US" sz="1800" dirty="0"/>
+          </a:p>
+        </p:txBody>
+      </p:sp>
+      <p:sp>
+        <p:nvSpPr>
+          <p:cNvPr id="10" name="Shape 8"/>
+          <p:cNvSpPr/>
+          <p:nvPr/>
+        </p:nvSpPr>
+        <p:spPr>
+          <a:xfrm>
+            <a:off x="548640" y="3611880"/>
+            <a:ext cx="5394960" cy="713232"/>
+          </a:xfrm>
+          <a:prstGeom prst="roundRect">
+            <a:avLst>
+              <a:gd name="adj" fmla="val 12821"/>
+            </a:avLst>
+          </a:prstGeom>
+          <a:solidFill>
+            <a:srgbClr val="EEF3F4"/>
+          </a:solidFill>
+          <a:ln/>
+        </p:spPr>
+      </p:sp>
+      <p:sp>
+        <p:nvSpPr>
+          <p:cNvPr id="11" name="Text 9"/>
+          <p:cNvSpPr txBox="1"/>
+          <p:nvPr/>
+        </p:nvSpPr>
+        <p:spPr>
+          <a:xfrm>
+            <a:off x="777240" y="3611880"/>
+            <a:ext cx="3291840" cy="713232"/>
+          </a:xfrm>
+          <a:prstGeom prst="rect">
+            <a:avLst/>
+          </a:prstGeom>
+          <a:noFill/>
+          <a:ln/>
+        </p:spPr>
+        <p:txBody>
+          <a:bodyPr wrap="square" lIns="0" tIns="0" rIns="0" bIns="0" rtlCol="0" anchor="ctr"/>
+          <a:lstStyle/>
+          <a:p>
+            <a:pPr indent="0" marL="0">
+              <a:buNone/>
+            </a:pPr>
+            <a:r>
+              <a:rPr lang="en-US" sz="1800" b="1" dirty="0">
+                <a:solidFill>
+                  <a:srgbClr val="0F4C5C"/>
+                </a:solidFill>
+                <a:latin typeface="Courier New" pitchFamily="34" charset="0"/>
+                <a:ea typeface="Courier New" pitchFamily="34" charset="-122"/>
+                <a:cs typeface="Courier New" pitchFamily="34" charset="-120"/>
+              </a:rPr>
+              <a:t>x[3:] </a:t>
+            </a:r>
+            <a:pPr indent="0" marL="0">
+              <a:buNone/>
+            </a:pPr>
+            <a:r>
+              <a:rPr lang="en-US" sz="1800" dirty="0">
+                <a:solidFill>
+                  <a:srgbClr val="5C6F7B"/>
+                </a:solidFill>
+                <a:latin typeface="Courier New" pitchFamily="34" charset="0"/>
+                <a:ea typeface="Courier New" pitchFamily="34" charset="-122"/>
+                <a:cs typeface="Courier New" pitchFamily="34" charset="-120"/>
+              </a:rPr>
+              <a:t>  = x[3:6]</a:t>
+            </a:r>
+            <a:endParaRPr lang="en-US" sz="1800" dirty="0"/>
+          </a:p>
+        </p:txBody>
+      </p:sp>
+      <p:sp>
+        <p:nvSpPr>
+          <p:cNvPr id="12" name="Text 10"/>
+          <p:cNvSpPr txBox="1"/>
+          <p:nvPr/>
+        </p:nvSpPr>
+        <p:spPr>
+          <a:xfrm>
+            <a:off x="4114800" y="3611880"/>
+            <a:ext cx="1691640" cy="713232"/>
+          </a:xfrm>
+          <a:prstGeom prst="rect">
+            <a:avLst/>
+          </a:prstGeom>
+          <a:noFill/>
+          <a:ln/>
+        </p:spPr>
+        <p:txBody>
+          <a:bodyPr wrap="square" lIns="0" tIns="0" rIns="0" bIns="0" rtlCol="0" anchor="ctr"/>
+          <a:lstStyle/>
+          <a:p>
+            <a:pPr indent="0" marL="0">
+              <a:buNone/>
+            </a:pPr>
+            <a:r>
+              <a:rPr lang="en-US" sz="1800" dirty="0">
+                <a:solidFill>
+                  <a:srgbClr val="1F2A30"/>
+                </a:solidFill>
+                <a:latin typeface="Courier New" pitchFamily="34" charset="0"/>
+                <a:ea typeface="Courier New" pitchFamily="34" charset="-122"/>
+                <a:cs typeface="Courier New" pitchFamily="34" charset="-120"/>
+              </a:rPr>
+              <a:t>D E F</a:t>
+            </a:r>
+            <a:endParaRPr lang="en-US" sz="1800" dirty="0"/>
+          </a:p>
+        </p:txBody>
+      </p:sp>
+      <p:sp>
+        <p:nvSpPr>
+          <p:cNvPr id="13" name="Shape 11"/>
+          <p:cNvSpPr/>
+          <p:nvPr/>
+        </p:nvSpPr>
+        <p:spPr>
+          <a:xfrm>
+            <a:off x="548640" y="4480560"/>
+            <a:ext cx="5394960" cy="713232"/>
+          </a:xfrm>
+          <a:prstGeom prst="roundRect">
+            <a:avLst>
+              <a:gd name="adj" fmla="val 12821"/>
+            </a:avLst>
+          </a:prstGeom>
+          <a:solidFill>
+            <a:srgbClr val="EEF3F4"/>
+          </a:solidFill>
+          <a:ln/>
+        </p:spPr>
+      </p:sp>
+      <p:sp>
+        <p:nvSpPr>
+          <p:cNvPr id="14" name="Text 12"/>
+          <p:cNvSpPr txBox="1"/>
+          <p:nvPr/>
+        </p:nvSpPr>
+        <p:spPr>
+          <a:xfrm>
+            <a:off x="777240" y="4480560"/>
+            <a:ext cx="3291840" cy="713232"/>
+          </a:xfrm>
+          <a:prstGeom prst="rect">
+            <a:avLst/>
+          </a:prstGeom>
+          <a:noFill/>
+          <a:ln/>
+        </p:spPr>
+        <p:txBody>
+          <a:bodyPr wrap="square" lIns="0" tIns="0" rIns="0" bIns="0" rtlCol="0" anchor="ctr"/>
+          <a:lstStyle/>
+          <a:p>
+            <a:pPr indent="0" marL="0">
+              <a:buNone/>
+            </a:pPr>
+            <a:r>
+              <a:rPr lang="en-US" sz="1800" b="1" dirty="0">
+                <a:solidFill>
+                  <a:srgbClr val="0F4C5C"/>
+                </a:solidFill>
+                <a:latin typeface="Courier New" pitchFamily="34" charset="0"/>
+                <a:ea typeface="Courier New" pitchFamily="34" charset="-122"/>
+                <a:cs typeface="Courier New" pitchFamily="34" charset="-120"/>
+              </a:rPr>
+              <a:t>x[:]  </a:t>
+            </a:r>
+            <a:pPr indent="0" marL="0">
+              <a:buNone/>
+            </a:pPr>
+            <a:r>
+              <a:rPr lang="en-US" sz="1800" dirty="0">
+                <a:solidFill>
+                  <a:srgbClr val="5C6F7B"/>
+                </a:solidFill>
+                <a:latin typeface="Courier New" pitchFamily="34" charset="0"/>
+                <a:ea typeface="Courier New" pitchFamily="34" charset="-122"/>
+                <a:cs typeface="Courier New" pitchFamily="34" charset="-120"/>
+              </a:rPr>
+              <a:t>  = x[0:6]</a:t>
+            </a:r>
+            <a:endParaRPr lang="en-US" sz="1800" dirty="0"/>
+          </a:p>
+        </p:txBody>
+      </p:sp>
+      <p:sp>
+        <p:nvSpPr>
+          <p:cNvPr id="15" name="Text 13"/>
+          <p:cNvSpPr txBox="1"/>
+          <p:nvPr/>
+        </p:nvSpPr>
+        <p:spPr>
+          <a:xfrm>
+            <a:off x="4114800" y="4480560"/>
+            <a:ext cx="1691640" cy="713232"/>
+          </a:xfrm>
+          <a:prstGeom prst="rect">
+            <a:avLst/>
+          </a:prstGeom>
+          <a:noFill/>
+          <a:ln/>
+        </p:spPr>
+        <p:txBody>
+          <a:bodyPr wrap="square" lIns="0" tIns="0" rIns="0" bIns="0" rtlCol="0" anchor="ctr"/>
+          <a:lstStyle/>
+          <a:p>
+            <a:pPr indent="0" marL="0">
+              <a:buNone/>
+            </a:pPr>
+            <a:r>
+              <a:rPr lang="en-US" sz="1800" dirty="0">
+                <a:solidFill>
+                  <a:srgbClr val="1F2A30"/>
+                </a:solidFill>
+                <a:latin typeface="Courier New" pitchFamily="34" charset="0"/>
+                <a:ea typeface="Courier New" pitchFamily="34" charset="-122"/>
+                <a:cs typeface="Courier New" pitchFamily="34" charset="-120"/>
+              </a:rPr>
+              <a:t>tutto</a:t>
+            </a:r>
+            <a:endParaRPr lang="en-US" sz="1800" dirty="0"/>
+          </a:p>
+        </p:txBody>
+      </p:sp>
+      <p:sp>
+        <p:nvSpPr>
+          <p:cNvPr id="16" name="Shape 14"/>
+          <p:cNvSpPr/>
+          <p:nvPr/>
+        </p:nvSpPr>
+        <p:spPr>
+          <a:xfrm>
+            <a:off x="6217920" y="2743200"/>
+            <a:ext cx="5394960" cy="713232"/>
+          </a:xfrm>
+          <a:prstGeom prst="roundRect">
+            <a:avLst>
+              <a:gd name="adj" fmla="val 12821"/>
+            </a:avLst>
+          </a:prstGeom>
+          <a:solidFill>
+            <a:srgbClr val="EEF3F4"/>
+          </a:solidFill>
+          <a:ln/>
+        </p:spPr>
+      </p:sp>
+      <p:sp>
+        <p:nvSpPr>
+          <p:cNvPr id="17" name="Text 15"/>
+          <p:cNvSpPr txBox="1"/>
+          <p:nvPr/>
+        </p:nvSpPr>
+        <p:spPr>
+          <a:xfrm>
+            <a:off x="6446520" y="2743200"/>
+            <a:ext cx="3291840" cy="713232"/>
+          </a:xfrm>
+          <a:prstGeom prst="rect">
+            <a:avLst/>
+          </a:prstGeom>
+          <a:noFill/>
+          <a:ln/>
+        </p:spPr>
+        <p:txBody>
+          <a:bodyPr wrap="square" lIns="0" tIns="0" rIns="0" bIns="0" rtlCol="0" anchor="ctr"/>
+          <a:lstStyle/>
+          <a:p>
+            <a:pPr indent="0" marL="0">
+              <a:buNone/>
+            </a:pPr>
+            <a:r>
+              <a:rPr lang="en-US" sz="1800" b="1" dirty="0">
+                <a:solidFill>
+                  <a:srgbClr val="0F4C5C"/>
+                </a:solidFill>
+                <a:latin typeface="Courier New" pitchFamily="34" charset="0"/>
+                <a:ea typeface="Courier New" pitchFamily="34" charset="-122"/>
+                <a:cs typeface="Courier New" pitchFamily="34" charset="-120"/>
+              </a:rPr>
+              <a:t>x[::2]</a:t>
+            </a:r>
+            <a:pPr indent="0" marL="0">
+              <a:buNone/>
+            </a:pPr>
+            <a:endParaRPr lang="en-US" sz="1800" dirty="0"/>
+          </a:p>
+        </p:txBody>
+      </p:sp>
+      <p:sp>
+        <p:nvSpPr>
+          <p:cNvPr id="18" name="Text 16"/>
+          <p:cNvSpPr txBox="1"/>
+          <p:nvPr/>
+        </p:nvSpPr>
+        <p:spPr>
+          <a:xfrm>
+            <a:off x="9784080" y="2743200"/>
+            <a:ext cx="1691640" cy="713232"/>
+          </a:xfrm>
+          <a:prstGeom prst="rect">
+            <a:avLst/>
+          </a:prstGeom>
+          <a:noFill/>
+          <a:ln/>
+        </p:spPr>
+        <p:txBody>
+          <a:bodyPr wrap="square" lIns="0" tIns="0" rIns="0" bIns="0" rtlCol="0" anchor="ctr"/>
+          <a:lstStyle/>
+          <a:p>
+            <a:pPr indent="0" marL="0">
+              <a:buNone/>
+            </a:pPr>
+            <a:r>
+              <a:rPr lang="en-US" sz="1800" dirty="0">
+                <a:solidFill>
+                  <a:srgbClr val="1F2A30"/>
+                </a:solidFill>
+                <a:latin typeface="Courier New" pitchFamily="34" charset="0"/>
+                <a:ea typeface="Courier New" pitchFamily="34" charset="-122"/>
+                <a:cs typeface="Courier New" pitchFamily="34" charset="-120"/>
+              </a:rPr>
+              <a:t>A C E</a:t>
+            </a:r>
+            <a:endParaRPr lang="en-US" sz="1800" dirty="0"/>
+          </a:p>
+        </p:txBody>
+      </p:sp>
+      <p:sp>
+        <p:nvSpPr>
+          <p:cNvPr id="19" name="Shape 17"/>
+          <p:cNvSpPr/>
+          <p:nvPr/>
+        </p:nvSpPr>
+        <p:spPr>
+          <a:xfrm>
+            <a:off x="6217920" y="3611880"/>
+            <a:ext cx="5394960" cy="713232"/>
+          </a:xfrm>
+          <a:prstGeom prst="roundRect">
+            <a:avLst>
+              <a:gd name="adj" fmla="val 12821"/>
+            </a:avLst>
+          </a:prstGeom>
+          <a:solidFill>
+            <a:srgbClr val="EEF3F4"/>
+          </a:solidFill>
+          <a:ln/>
+        </p:spPr>
+      </p:sp>
+      <p:sp>
+        <p:nvSpPr>
+          <p:cNvPr id="20" name="Text 18"/>
+          <p:cNvSpPr txBox="1"/>
+          <p:nvPr/>
+        </p:nvSpPr>
+        <p:spPr>
+          <a:xfrm>
+            <a:off x="6446520" y="3611880"/>
+            <a:ext cx="3291840" cy="713232"/>
+          </a:xfrm>
+          <a:prstGeom prst="rect">
+            <a:avLst/>
+          </a:prstGeom>
+          <a:noFill/>
+          <a:ln/>
+        </p:spPr>
+        <p:txBody>
+          <a:bodyPr wrap="square" lIns="0" tIns="0" rIns="0" bIns="0" rtlCol="0" anchor="ctr"/>
+          <a:lstStyle/>
+          <a:p>
+            <a:pPr indent="0" marL="0">
+              <a:buNone/>
+            </a:pPr>
+            <a:r>
+              <a:rPr lang="en-US" sz="1800" b="1" dirty="0">
+                <a:solidFill>
+                  <a:srgbClr val="0F4C5C"/>
+                </a:solidFill>
+                <a:latin typeface="Courier New" pitchFamily="34" charset="0"/>
+                <a:ea typeface="Courier New" pitchFamily="34" charset="-122"/>
+                <a:cs typeface="Courier New" pitchFamily="34" charset="-120"/>
+              </a:rPr>
+              <a:t>x[1::2]</a:t>
+            </a:r>
+            <a:pPr indent="0" marL="0">
+              <a:buNone/>
+            </a:pPr>
+            <a:endParaRPr lang="en-US" sz="1800" dirty="0"/>
+          </a:p>
+        </p:txBody>
+      </p:sp>
+      <p:sp>
+        <p:nvSpPr>
+          <p:cNvPr id="21" name="Text 19"/>
+          <p:cNvSpPr txBox="1"/>
+          <p:nvPr/>
+        </p:nvSpPr>
+        <p:spPr>
+          <a:xfrm>
+            <a:off x="9784080" y="3611880"/>
+            <a:ext cx="1691640" cy="713232"/>
+          </a:xfrm>
+          <a:prstGeom prst="rect">
+            <a:avLst/>
+          </a:prstGeom>
+          <a:noFill/>
+          <a:ln/>
+        </p:spPr>
+        <p:txBody>
+          <a:bodyPr wrap="square" lIns="0" tIns="0" rIns="0" bIns="0" rtlCol="0" anchor="ctr"/>
+          <a:lstStyle/>
+          <a:p>
+            <a:pPr indent="0" marL="0">
+              <a:buNone/>
+            </a:pPr>
+            <a:r>
+              <a:rPr lang="en-US" sz="1800" dirty="0">
+                <a:solidFill>
+                  <a:srgbClr val="1F2A30"/>
+                </a:solidFill>
+                <a:latin typeface="Courier New" pitchFamily="34" charset="0"/>
+                <a:ea typeface="Courier New" pitchFamily="34" charset="-122"/>
+                <a:cs typeface="Courier New" pitchFamily="34" charset="-120"/>
+              </a:rPr>
+              <a:t>B D F</a:t>
+            </a:r>
+            <a:endParaRPr lang="en-US" sz="1800" dirty="0"/>
+          </a:p>
+        </p:txBody>
+      </p:sp>
+      <p:sp>
+        <p:nvSpPr>
+          <p:cNvPr id="22" name="Shape 20"/>
+          <p:cNvSpPr/>
+          <p:nvPr/>
+        </p:nvSpPr>
+        <p:spPr>
+          <a:xfrm>
+            <a:off x="6217920" y="4480560"/>
+            <a:ext cx="5394960" cy="713232"/>
+          </a:xfrm>
+          <a:prstGeom prst="roundRect">
+            <a:avLst>
+              <a:gd name="adj" fmla="val 12821"/>
+            </a:avLst>
+          </a:prstGeom>
+          <a:solidFill>
+            <a:srgbClr val="EEF3F4"/>
+          </a:solidFill>
+          <a:ln/>
+        </p:spPr>
+      </p:sp>
+      <p:sp>
+        <p:nvSpPr>
+          <p:cNvPr id="23" name="Text 21"/>
+          <p:cNvSpPr txBox="1"/>
+          <p:nvPr/>
+        </p:nvSpPr>
+        <p:spPr>
+          <a:xfrm>
+            <a:off x="6446520" y="4480560"/>
+            <a:ext cx="3291840" cy="713232"/>
+          </a:xfrm>
+          <a:prstGeom prst="rect">
+            <a:avLst/>
+          </a:prstGeom>
+          <a:noFill/>
+          <a:ln/>
+        </p:spPr>
+        <p:txBody>
+          <a:bodyPr wrap="square" lIns="0" tIns="0" rIns="0" bIns="0" rtlCol="0" anchor="ctr"/>
+          <a:lstStyle/>
+          <a:p>
+            <a:pPr indent="0" marL="0">
+              <a:buNone/>
+            </a:pPr>
+            <a:r>
+              <a:rPr lang="en-US" sz="1800" b="1" dirty="0">
+                <a:solidFill>
+                  <a:srgbClr val="0F4C5C"/>
+                </a:solidFill>
+                <a:latin typeface="Courier New" pitchFamily="34" charset="0"/>
+                <a:ea typeface="Courier New" pitchFamily="34" charset="-122"/>
+                <a:cs typeface="Courier New" pitchFamily="34" charset="-120"/>
+              </a:rPr>
+              <a:t>x[::-1]</a:t>
+            </a:r>
+            <a:pPr indent="0" marL="0">
+              <a:buNone/>
+            </a:pPr>
+            <a:endParaRPr lang="en-US" sz="1800" dirty="0"/>
+          </a:p>
+        </p:txBody>
+      </p:sp>
+      <p:sp>
+        <p:nvSpPr>
+          <p:cNvPr id="24" name="Text 22"/>
+          <p:cNvSpPr txBox="1"/>
+          <p:nvPr/>
+        </p:nvSpPr>
+        <p:spPr>
+          <a:xfrm>
+            <a:off x="9784080" y="4480560"/>
+            <a:ext cx="1691640" cy="713232"/>
+          </a:xfrm>
+          <a:prstGeom prst="rect">
+            <a:avLst/>
+          </a:prstGeom>
+          <a:noFill/>
+          <a:ln/>
+        </p:spPr>
+        <p:txBody>
+          <a:bodyPr wrap="square" lIns="0" tIns="0" rIns="0" bIns="0" rtlCol="0" anchor="ctr"/>
+          <a:lstStyle/>
+          <a:p>
+            <a:pPr indent="0" marL="0">
+              <a:buNone/>
+            </a:pPr>
+            <a:r>
+              <a:rPr lang="en-US" sz="1800" dirty="0">
+                <a:solidFill>
+                  <a:srgbClr val="1F2A30"/>
+                </a:solidFill>
+                <a:latin typeface="Courier New" pitchFamily="34" charset="0"/>
+                <a:ea typeface="Courier New" pitchFamily="34" charset="-122"/>
+                <a:cs typeface="Courier New" pitchFamily="34" charset="-120"/>
+              </a:rPr>
+              <a:t>F E D C B A</a:t>
+            </a:r>
+            <a:endParaRPr lang="en-US" sz="1800" dirty="0"/>
+          </a:p>
+        </p:txBody>
+      </p:sp>
+      <p:sp>
+        <p:nvSpPr>
+          <p:cNvPr id="25" name="Text 23"/>
+          <p:cNvSpPr txBox="1"/>
+          <p:nvPr/>
+        </p:nvSpPr>
+        <p:spPr>
+          <a:xfrm>
+            <a:off x="548640" y="5486400"/>
+            <a:ext cx="11064240" cy="457200"/>
+          </a:xfrm>
+          <a:prstGeom prst="rect">
+            <a:avLst/>
+          </a:prstGeom>
+          <a:noFill/>
+          <a:ln/>
+        </p:spPr>
+        <p:txBody>
+          <a:bodyPr wrap="square" lIns="0" tIns="0" rIns="0" bIns="0" rtlCol="0" anchor="ctr"/>
+          <a:lstStyle/>
+          <a:p>
+            <a:pPr indent="0" marL="0">
+              <a:buNone/>
+            </a:pPr>
+            <a:r>
+              <a:rPr lang="en-US" sz="1700" dirty="0">
+                <a:solidFill>
+                  <a:srgbClr val="1F2A30"/>
+                </a:solidFill>
+                <a:latin typeface="Courier New" pitchFamily="34" charset="0"/>
+                <a:ea typeface="Courier New" pitchFamily="34" charset="-122"/>
+                <a:cs typeface="Courier New" pitchFamily="34" charset="-120"/>
+              </a:rPr>
+              <a:t>x = </a:t>
+            </a:r>
+            <a:pPr indent="0" marL="0">
+              <a:buNone/>
+            </a:pPr>
+            <a:r>
+              <a:rPr lang="en-US" sz="1700" b="1" dirty="0">
+                <a:solidFill>
+                  <a:srgbClr val="1F2A30"/>
+                </a:solidFill>
+                <a:latin typeface="Courier New" pitchFamily="34" charset="0"/>
+                <a:ea typeface="Courier New" pitchFamily="34" charset="-122"/>
+                <a:cs typeface="Courier New" pitchFamily="34" charset="-120"/>
+              </a:rPr>
+              <a:t>A B C D E F</a:t>
+            </a:r>
+            <a:pPr indent="0" marL="0">
+              <a:buNone/>
+            </a:pPr>
+            <a:r>
+              <a:rPr lang="en-US" sz="1700" dirty="0">
+                <a:solidFill>
+                  <a:srgbClr val="1F2A30"/>
+                </a:solidFill>
+              </a:rPr>
+              <a:t>    Con il passo negativo si va all'indietro: </a:t>
+            </a:r>
+            <a:pPr indent="0" marL="0">
+              <a:buNone/>
+            </a:pPr>
+            <a:r>
+              <a:rPr lang="en-US" sz="1700" b="1" dirty="0">
+                <a:solidFill>
+                  <a:srgbClr val="1F2A30"/>
+                </a:solidFill>
+                <a:latin typeface="Courier New" pitchFamily="34" charset="0"/>
+                <a:ea typeface="Courier New" pitchFamily="34" charset="-122"/>
+                <a:cs typeface="Courier New" pitchFamily="34" charset="-120"/>
+              </a:rPr>
+              <a:t>[::-1]</a:t>
+            </a:r>
+            <a:pPr indent="0" marL="0">
+              <a:buNone/>
+            </a:pPr>
+            <a:r>
+              <a:rPr lang="en-US" sz="1700" dirty="0">
+                <a:solidFill>
+                  <a:srgbClr val="1F2A30"/>
+                </a:solidFill>
+              </a:rPr>
+              <a:t> inverte.</a:t>
+            </a:r>
+            <a:endParaRPr lang="en-US" sz="1700" dirty="0"/>
+          </a:p>
+        </p:txBody>
+      </p:sp>
+      <p:sp>
+        <p:nvSpPr>
+          <p:cNvPr id="25" name="Slide Number Placeholder 0"/>
+          <p:cNvSpPr>
+            <a:spLocks noGrp="1"/>
+          </p:cNvSpPr>
+          <p:nvPr>
+            <p:ph type="sldNum" sz="quarter" idx="4294967295"/>
+          </p:nvPr>
+        </p:nvSpPr>
+        <p:spPr>
+          <a:xfrm>
+            <a:off x="11155680" y="6400800"/>
+            <a:ext cx="457200" cy="274320"/>
+          </a:xfrm>
+          <a:prstGeom prst="rect">
+            <a:avLst/>
+          </a:prstGeom>
+          <a:extLst>
+            <a:ext uri="{C572A759-6A51-4108-AA02-DFA0A04FC94B}">
+              <ma14:wrappingTextBoxFlag xmlns:ma14="http://schemas.microsoft.com/office/mac/drawingml/2011/main" val="0"/>
+            </a:ext>
+          </a:extLst>
+        </p:spPr>
+        <p:txBody>
+          <a:bodyPr/>
+          <a:lstStyle>
+            <a:lvl1pPr>
+              <a:defRPr sz="1000">
+                <a:solidFill>
+                  <a:srgbClr val="5C6F7B"/>
+                </a:solidFill>
+              </a:defRPr>
+            </a:lvl1pPr>
+          </a:lstStyle>
+          <a:p>
+            <a:pPr algn="r"/>
+            <a:fld id="{F7021451-1387-4CA6-816F-3879F97B5CBC}" type="slidenum">
+              <a:rPr b="0" lang="en-US"/>
+              <a:t>8</a:t>
+            </a:fld>
+            <a:endParaRPr lang="en-US"/>
+          </a:p>
+        </p:txBody>
+      </p:sp>
+    </p:spTree>
+  </p:cSld>
+  <p:clrMapOvr>
+    <a:masterClrMapping/>
+  </p:clrMapOvr>
+</p:sld>
+</file>
+
+<file path=ppt/slides/slide9.xml><?xml version="1.0" encoding="utf-8"?>
+<p:sld xmlns:a="http://schemas.openxmlformats.org/drawingml/2006/main" xmlns:r="http://schemas.openxmlformats.org/officeDocument/2006/relationships" xmlns:p="http://schemas.openxmlformats.org/presentationml/2006/main">
+  <p:cSld name="Slide 9">
+    <p:spTree>
+      <p:nvGrpSpPr>
+        <p:cNvPr id="1" name=""/>
+        <p:cNvGrpSpPr/>
+        <p:nvPr/>
+      </p:nvGrpSpPr>
+      <p:grpSpPr>
+        <a:xfrm>
+          <a:off x="0" y="0"/>
+          <a:ext cx="0" cy="0"/>
+          <a:chOff x="0" y="0"/>
+          <a:chExt cx="0" cy="0"/>
+        </a:xfrm>
+      </p:grpSpPr>
+      <p:sp>
+        <p:nvSpPr>
+          <p:cNvPr id="2" name="Text 0"/>
+          <p:cNvSpPr/>
+          <p:nvPr>
+            <p:ph idx="100" type="title" hasCustomPrompt="1"/>
+          </p:nvPr>
+        </p:nvSpPr>
+        <p:spPr>
+          <a:xfrm>
+            <a:off x="548640" y="365760"/>
+            <a:ext cx="11064240" cy="822960"/>
+          </a:xfrm>
+          <a:prstGeom prst="rect">
+            <a:avLst/>
+          </a:prstGeom>
+          <a:noFill/>
+          <a:ln/>
+        </p:spPr>
+        <p:txBody>
+          <a:bodyPr wrap="square" lIns="0" tIns="0" rIns="0" bIns="0" rtlCol="0" anchor="ctr"/>
+          <a:lstStyle/>
+          <a:p>
+            <a:pPr algn="l" indent="0" marL="0">
+              <a:buNone/>
+            </a:pPr>
+            <a:r>
+              <a:rPr lang="en-US" sz="3600" b="1" dirty="0">
+                <a:solidFill>
+                  <a:srgbClr val="0F4C5C"/>
+                </a:solidFill>
+              </a:rPr>
               <a:t>iloc è come un intervallo di Excel</a:t>
             </a:r>
             <a:endParaRPr lang="en-US" sz="3600" dirty="0"/>
@@ -12493,7 +14251,7 @@
       </p:sp>
       <p:graphicFrame>
         <p:nvGraphicFramePr>
-          <p:cNvPr id="9" name="Table 0"/>
+          <p:cNvPr id="10" name="Table 0"/>
           <p:cNvGraphicFramePr>
             <a:graphicFrameLocks noGrp="1"/>
           </p:cNvGraphicFramePr>
@@ -13112,682 +14870,6 @@
               <a:t>Stesse celle: cambiano solo i numeri.</a:t>
             </a:r>
             <a:endParaRPr lang="en-US" sz="1700" dirty="0"/>
-          </a:p>
-        </p:txBody>
-      </p:sp>
-      <p:sp>
-        <p:nvSpPr>
-          <p:cNvPr id="25" name="Slide Number Placeholder 0"/>
-          <p:cNvSpPr>
-            <a:spLocks noGrp="1"/>
-          </p:cNvSpPr>
-          <p:nvPr>
-            <p:ph type="sldNum" sz="quarter" idx="4294967295"/>
-          </p:nvPr>
-        </p:nvSpPr>
-        <p:spPr>
-          <a:xfrm>
-            <a:off x="11155680" y="6400800"/>
-            <a:ext cx="457200" cy="274320"/>
-          </a:xfrm>
-          <a:prstGeom prst="rect">
-            <a:avLst/>
-          </a:prstGeom>
-          <a:extLst>
-            <a:ext uri="{C572A759-6A51-4108-AA02-DFA0A04FC94B}">
-              <ma14:wrappingTextBoxFlag xmlns:ma14="http://schemas.microsoft.com/office/mac/drawingml/2011/main" val="0"/>
-            </a:ext>
-          </a:extLst>
-        </p:spPr>
-        <p:txBody>
-          <a:bodyPr/>
-          <a:lstStyle>
-            <a:lvl1pPr>
-              <a:defRPr sz="1000">
-                <a:solidFill>
-                  <a:srgbClr val="5C6F7B"/>
-                </a:solidFill>
-              </a:defRPr>
-            </a:lvl1pPr>
-          </a:lstStyle>
-          <a:p>
-            <a:pPr algn="r"/>
-            <a:fld id="{F7021451-1387-4CA6-816F-3879F97B5CBC}" type="slidenum">
-              <a:rPr b="0" lang="en-US"/>
-              <a:t>8</a:t>
-            </a:fld>
-            <a:endParaRPr lang="en-US"/>
-          </a:p>
-        </p:txBody>
-      </p:sp>
-    </p:spTree>
-  </p:cSld>
-  <p:clrMapOvr>
-    <a:masterClrMapping/>
-  </p:clrMapOvr>
-</p:sld>
-</file>
-
-<file path=ppt/slides/slide9.xml><?xml version="1.0" encoding="utf-8"?>
-<p:sld xmlns:a="http://schemas.openxmlformats.org/drawingml/2006/main" xmlns:r="http://schemas.openxmlformats.org/officeDocument/2006/relationships" xmlns:p="http://schemas.openxmlformats.org/presentationml/2006/main">
-  <p:cSld name="Slide 9">
-    <p:spTree>
-      <p:nvGrpSpPr>
-        <p:cNvPr id="1" name=""/>
-        <p:cNvGrpSpPr/>
-        <p:nvPr/>
-      </p:nvGrpSpPr>
-      <p:grpSpPr>
-        <a:xfrm>
-          <a:off x="0" y="0"/>
-          <a:ext cx="0" cy="0"/>
-          <a:chOff x="0" y="0"/>
-          <a:chExt cx="0" cy="0"/>
-        </a:xfrm>
-      </p:grpSpPr>
-      <p:sp>
-        <p:nvSpPr>
-          <p:cNvPr id="2" name="Text 0"/>
-          <p:cNvSpPr/>
-          <p:nvPr>
-            <p:ph idx="100" type="title" hasCustomPrompt="1"/>
-          </p:nvPr>
-        </p:nvSpPr>
-        <p:spPr>
-          <a:xfrm>
-            <a:off x="548640" y="365760"/>
-            <a:ext cx="11064240" cy="822960"/>
-          </a:xfrm>
-          <a:prstGeom prst="rect">
-            <a:avLst/>
-          </a:prstGeom>
-          <a:noFill/>
-          <a:ln/>
-        </p:spPr>
-        <p:txBody>
-          <a:bodyPr wrap="square" lIns="0" tIns="0" rIns="0" bIns="0" rtlCol="0" anchor="ctr"/>
-          <a:lstStyle/>
-          <a:p>
-            <a:pPr algn="l" indent="0" marL="0">
-              <a:buNone/>
-            </a:pPr>
-            <a:r>
-              <a:rPr lang="en-US" sz="3600" b="1" dirty="0">
-                <a:solidFill>
-                  <a:srgbClr val="0F4C5C"/>
-                </a:solidFill>
-              </a:rPr>
-              <a:t>Fare domande a un oggetto</a:t>
-            </a:r>
-            <a:endParaRPr lang="en-US" sz="3600" dirty="0"/>
-          </a:p>
-        </p:txBody>
-      </p:sp>
-      <p:sp>
-        <p:nvSpPr>
-          <p:cNvPr id="3" name="Text 1"/>
-          <p:cNvSpPr txBox="1"/>
-          <p:nvPr/>
-        </p:nvSpPr>
-        <p:spPr>
-          <a:xfrm>
-            <a:off x="548640" y="1645920"/>
-            <a:ext cx="5349240" cy="457200"/>
-          </a:xfrm>
-          <a:prstGeom prst="rect">
-            <a:avLst/>
-          </a:prstGeom>
-          <a:noFill/>
-          <a:ln/>
-        </p:spPr>
-        <p:txBody>
-          <a:bodyPr wrap="square" lIns="0" tIns="0" rIns="0" bIns="0" rtlCol="0" anchor="ctr"/>
-          <a:lstStyle/>
-          <a:p>
-            <a:pPr indent="0" marL="0">
-              <a:buNone/>
-            </a:pPr>
-            <a:r>
-              <a:rPr lang="en-US" sz="2600" b="1" dirty="0">
-                <a:solidFill>
-                  <a:srgbClr val="0F4C5C"/>
-                </a:solidFill>
-              </a:rPr>
-              <a:t>Metodo</a:t>
-            </a:r>
-            <a:endParaRPr lang="en-US" sz="2600" dirty="0"/>
-          </a:p>
-        </p:txBody>
-      </p:sp>
-      <p:sp>
-        <p:nvSpPr>
-          <p:cNvPr id="4" name="Text 2"/>
-          <p:cNvSpPr txBox="1"/>
-          <p:nvPr/>
-        </p:nvSpPr>
-        <p:spPr>
-          <a:xfrm>
-            <a:off x="548640" y="2103120"/>
-            <a:ext cx="5349240" cy="411480"/>
-          </a:xfrm>
-          <a:prstGeom prst="rect">
-            <a:avLst/>
-          </a:prstGeom>
-          <a:noFill/>
-          <a:ln/>
-        </p:spPr>
-        <p:txBody>
-          <a:bodyPr wrap="square" lIns="0" tIns="0" rIns="0" bIns="0" rtlCol="0" anchor="ctr"/>
-          <a:lstStyle/>
-          <a:p>
-            <a:pPr indent="0" marL="0">
-              <a:buNone/>
-            </a:pPr>
-            <a:r>
-              <a:rPr lang="en-US" sz="1800" dirty="0">
-                <a:solidFill>
-                  <a:srgbClr val="5C6F7B"/>
-                </a:solidFill>
-              </a:rPr>
-              <a:t>un'azione: ha le parentesi</a:t>
-            </a:r>
-            <a:endParaRPr lang="en-US" sz="1800" dirty="0"/>
-          </a:p>
-        </p:txBody>
-      </p:sp>
-      <p:sp>
-        <p:nvSpPr>
-          <p:cNvPr id="5" name="card-code"/>
-          <p:cNvSpPr/>
-          <p:nvPr/>
-        </p:nvSpPr>
-        <p:spPr>
-          <a:xfrm>
-            <a:off x="548640" y="2697480"/>
-            <a:ext cx="5349240" cy="1188720"/>
-          </a:xfrm>
-          <a:prstGeom prst="roundRect">
-            <a:avLst>
-              <a:gd name="adj" fmla="val 9231"/>
-            </a:avLst>
-          </a:prstGeom>
-          <a:solidFill>
-            <a:srgbClr val="1F2A30"/>
-          </a:solidFill>
-          <a:ln/>
-        </p:spPr>
-      </p:sp>
-      <p:sp>
-        <p:nvSpPr>
-          <p:cNvPr id="6" name="Text 4"/>
-          <p:cNvSpPr txBox="1"/>
-          <p:nvPr/>
-        </p:nvSpPr>
-        <p:spPr>
-          <a:xfrm>
-            <a:off x="777240" y="2834640"/>
-            <a:ext cx="1828800" cy="274320"/>
-          </a:xfrm>
-          <a:prstGeom prst="rect">
-            <a:avLst/>
-          </a:prstGeom>
-          <a:noFill/>
-          <a:ln/>
-        </p:spPr>
-        <p:txBody>
-          <a:bodyPr wrap="square" lIns="0" tIns="0" rIns="0" bIns="0" rtlCol="0" anchor="ctr"/>
-          <a:lstStyle/>
-          <a:p>
-            <a:pPr indent="0" marL="0">
-              <a:buNone/>
-            </a:pPr>
-            <a:r>
-              <a:rPr lang="en-US" sz="1100" b="1" spc="200" kern="0" dirty="0">
-                <a:solidFill>
-                  <a:srgbClr val="E09F3E"/>
-                </a:solidFill>
-              </a:rPr>
-              <a:t>PYTHON</a:t>
-            </a:r>
-            <a:endParaRPr lang="en-US" sz="1100" dirty="0"/>
-          </a:p>
-        </p:txBody>
-      </p:sp>
-      <p:sp>
-        <p:nvSpPr>
-          <p:cNvPr id="7" name="Text 5"/>
-          <p:cNvSpPr txBox="1"/>
-          <p:nvPr/>
-        </p:nvSpPr>
-        <p:spPr>
-          <a:xfrm>
-            <a:off x="777240" y="3154680"/>
-            <a:ext cx="4892040" cy="594360"/>
-          </a:xfrm>
-          <a:prstGeom prst="rect">
-            <a:avLst/>
-          </a:prstGeom>
-          <a:noFill/>
-          <a:ln/>
-        </p:spPr>
-        <p:txBody>
-          <a:bodyPr wrap="square" lIns="0" tIns="0" rIns="0" bIns="0" rtlCol="0" anchor="t"/>
-          <a:lstStyle/>
-          <a:p>
-            <a:pPr indent="0" marL="0">
-              <a:buNone/>
-            </a:pPr>
-            <a:r>
-              <a:rPr lang="en-US" sz="2200" dirty="0">
-                <a:solidFill>
-                  <a:srgbClr val="FFFFFF"/>
-                </a:solidFill>
-                <a:latin typeface="Courier New" pitchFamily="34" charset="0"/>
-                <a:ea typeface="Courier New" pitchFamily="34" charset="-122"/>
-                <a:cs typeface="Courier New" pitchFamily="34" charset="-120"/>
-              </a:rPr>
-              <a:t>df.head(3)</a:t>
-            </a:r>
-            <a:endParaRPr lang="en-US" sz="2200" dirty="0"/>
-          </a:p>
-        </p:txBody>
-      </p:sp>
-      <p:sp>
-        <p:nvSpPr>
-          <p:cNvPr id="8" name="card-out"/>
-          <p:cNvSpPr/>
-          <p:nvPr/>
-        </p:nvSpPr>
-        <p:spPr>
-          <a:xfrm>
-            <a:off x="548640" y="4069080"/>
-            <a:ext cx="5349240" cy="1188720"/>
-          </a:xfrm>
-          <a:prstGeom prst="roundRect">
-            <a:avLst>
-              <a:gd name="adj" fmla="val 9231"/>
-            </a:avLst>
-          </a:prstGeom>
-          <a:solidFill>
-            <a:srgbClr val="EEF3F4"/>
-          </a:solidFill>
-          <a:ln/>
-        </p:spPr>
-      </p:sp>
-      <p:sp>
-        <p:nvSpPr>
-          <p:cNvPr id="9" name="Text 7"/>
-          <p:cNvSpPr txBox="1"/>
-          <p:nvPr/>
-        </p:nvSpPr>
-        <p:spPr>
-          <a:xfrm>
-            <a:off x="777240" y="4206240"/>
-            <a:ext cx="1828800" cy="274320"/>
-          </a:xfrm>
-          <a:prstGeom prst="rect">
-            <a:avLst/>
-          </a:prstGeom>
-          <a:noFill/>
-          <a:ln/>
-        </p:spPr>
-        <p:txBody>
-          <a:bodyPr wrap="square" lIns="0" tIns="0" rIns="0" bIns="0" rtlCol="0" anchor="ctr"/>
-          <a:lstStyle/>
-          <a:p>
-            <a:pPr indent="0" marL="0">
-              <a:buNone/>
-            </a:pPr>
-            <a:r>
-              <a:rPr lang="en-US" sz="1100" b="1" spc="200" kern="0" dirty="0">
-                <a:solidFill>
-                  <a:srgbClr val="5C6F7B"/>
-                </a:solidFill>
-              </a:rPr>
-              <a:t>OUTPUT</a:t>
-            </a:r>
-            <a:endParaRPr lang="en-US" sz="1100" dirty="0"/>
-          </a:p>
-        </p:txBody>
-      </p:sp>
-      <p:sp>
-        <p:nvSpPr>
-          <p:cNvPr id="10" name="Text 8"/>
-          <p:cNvSpPr txBox="1"/>
-          <p:nvPr/>
-        </p:nvSpPr>
-        <p:spPr>
-          <a:xfrm>
-            <a:off x="777240" y="4526280"/>
-            <a:ext cx="4892040" cy="594360"/>
-          </a:xfrm>
-          <a:prstGeom prst="rect">
-            <a:avLst/>
-          </a:prstGeom>
-          <a:noFill/>
-          <a:ln/>
-        </p:spPr>
-        <p:txBody>
-          <a:bodyPr wrap="square" lIns="0" tIns="0" rIns="0" bIns="0" rtlCol="0" anchor="t"/>
-          <a:lstStyle/>
-          <a:p>
-            <a:pPr indent="0" marL="0">
-              <a:buNone/>
-            </a:pPr>
-            <a:r>
-              <a:rPr lang="en-US" sz="2000" dirty="0">
-                <a:solidFill>
-                  <a:srgbClr val="1F2A30"/>
-                </a:solidFill>
-                <a:latin typeface="Courier New" pitchFamily="34" charset="0"/>
-                <a:ea typeface="Courier New" pitchFamily="34" charset="-122"/>
-                <a:cs typeface="Courier New" pitchFamily="34" charset="-120"/>
-              </a:rPr>
-              <a:t>le prime 3 righe</a:t>
-            </a:r>
-            <a:endParaRPr lang="en-US" sz="2000" dirty="0"/>
-          </a:p>
-        </p:txBody>
-      </p:sp>
-      <p:sp>
-        <p:nvSpPr>
-          <p:cNvPr id="11" name="Text 9"/>
-          <p:cNvSpPr txBox="1"/>
-          <p:nvPr/>
-        </p:nvSpPr>
-        <p:spPr>
-          <a:xfrm>
-            <a:off x="6263640" y="1645920"/>
-            <a:ext cx="5349240" cy="457200"/>
-          </a:xfrm>
-          <a:prstGeom prst="rect">
-            <a:avLst/>
-          </a:prstGeom>
-          <a:noFill/>
-          <a:ln/>
-        </p:spPr>
-        <p:txBody>
-          <a:bodyPr wrap="square" lIns="0" tIns="0" rIns="0" bIns="0" rtlCol="0" anchor="ctr"/>
-          <a:lstStyle/>
-          <a:p>
-            <a:pPr indent="0" marL="0">
-              <a:buNone/>
-            </a:pPr>
-            <a:r>
-              <a:rPr lang="en-US" sz="2600" b="1" dirty="0">
-                <a:solidFill>
-                  <a:srgbClr val="0F4C5C"/>
-                </a:solidFill>
-              </a:rPr>
-              <a:t>Attributo</a:t>
-            </a:r>
-            <a:endParaRPr lang="en-US" sz="2600" dirty="0"/>
-          </a:p>
-        </p:txBody>
-      </p:sp>
-      <p:sp>
-        <p:nvSpPr>
-          <p:cNvPr id="12" name="Text 10"/>
-          <p:cNvSpPr txBox="1"/>
-          <p:nvPr/>
-        </p:nvSpPr>
-        <p:spPr>
-          <a:xfrm>
-            <a:off x="6263640" y="2103120"/>
-            <a:ext cx="5349240" cy="411480"/>
-          </a:xfrm>
-          <a:prstGeom prst="rect">
-            <a:avLst/>
-          </a:prstGeom>
-          <a:noFill/>
-          <a:ln/>
-        </p:spPr>
-        <p:txBody>
-          <a:bodyPr wrap="square" lIns="0" tIns="0" rIns="0" bIns="0" rtlCol="0" anchor="ctr"/>
-          <a:lstStyle/>
-          <a:p>
-            <a:pPr indent="0" marL="0">
-              <a:buNone/>
-            </a:pPr>
-            <a:r>
-              <a:rPr lang="en-US" sz="1800" dirty="0">
-                <a:solidFill>
-                  <a:srgbClr val="5C6F7B"/>
-                </a:solidFill>
-              </a:rPr>
-              <a:t>un'informazione: niente parentesi</a:t>
-            </a:r>
-            <a:endParaRPr lang="en-US" sz="1800" dirty="0"/>
-          </a:p>
-        </p:txBody>
-      </p:sp>
-      <p:sp>
-        <p:nvSpPr>
-          <p:cNvPr id="13" name="card-code"/>
-          <p:cNvSpPr/>
-          <p:nvPr/>
-        </p:nvSpPr>
-        <p:spPr>
-          <a:xfrm>
-            <a:off x="6263640" y="2697480"/>
-            <a:ext cx="5349240" cy="1188720"/>
-          </a:xfrm>
-          <a:prstGeom prst="roundRect">
-            <a:avLst>
-              <a:gd name="adj" fmla="val 9231"/>
-            </a:avLst>
-          </a:prstGeom>
-          <a:solidFill>
-            <a:srgbClr val="1F2A30"/>
-          </a:solidFill>
-          <a:ln/>
-        </p:spPr>
-      </p:sp>
-      <p:sp>
-        <p:nvSpPr>
-          <p:cNvPr id="14" name="Text 12"/>
-          <p:cNvSpPr txBox="1"/>
-          <p:nvPr/>
-        </p:nvSpPr>
-        <p:spPr>
-          <a:xfrm>
-            <a:off x="6492240" y="2834640"/>
-            <a:ext cx="1828800" cy="274320"/>
-          </a:xfrm>
-          <a:prstGeom prst="rect">
-            <a:avLst/>
-          </a:prstGeom>
-          <a:noFill/>
-          <a:ln/>
-        </p:spPr>
-        <p:txBody>
-          <a:bodyPr wrap="square" lIns="0" tIns="0" rIns="0" bIns="0" rtlCol="0" anchor="ctr"/>
-          <a:lstStyle/>
-          <a:p>
-            <a:pPr indent="0" marL="0">
-              <a:buNone/>
-            </a:pPr>
-            <a:r>
-              <a:rPr lang="en-US" sz="1100" b="1" spc="200" kern="0" dirty="0">
-                <a:solidFill>
-                  <a:srgbClr val="E09F3E"/>
-                </a:solidFill>
-              </a:rPr>
-              <a:t>PYTHON</a:t>
-            </a:r>
-            <a:endParaRPr lang="en-US" sz="1100" dirty="0"/>
-          </a:p>
-        </p:txBody>
-      </p:sp>
-      <p:sp>
-        <p:nvSpPr>
-          <p:cNvPr id="15" name="Text 13"/>
-          <p:cNvSpPr txBox="1"/>
-          <p:nvPr/>
-        </p:nvSpPr>
-        <p:spPr>
-          <a:xfrm>
-            <a:off x="6492240" y="3154680"/>
-            <a:ext cx="4892040" cy="594360"/>
-          </a:xfrm>
-          <a:prstGeom prst="rect">
-            <a:avLst/>
-          </a:prstGeom>
-          <a:noFill/>
-          <a:ln/>
-        </p:spPr>
-        <p:txBody>
-          <a:bodyPr wrap="square" lIns="0" tIns="0" rIns="0" bIns="0" rtlCol="0" anchor="t"/>
-          <a:lstStyle/>
-          <a:p>
-            <a:pPr indent="0" marL="0">
-              <a:buNone/>
-            </a:pPr>
-            <a:r>
-              <a:rPr lang="en-US" sz="2200" dirty="0">
-                <a:solidFill>
-                  <a:srgbClr val="FFFFFF"/>
-                </a:solidFill>
-                <a:latin typeface="Courier New" pitchFamily="34" charset="0"/>
-                <a:ea typeface="Courier New" pitchFamily="34" charset="-122"/>
-                <a:cs typeface="Courier New" pitchFamily="34" charset="-120"/>
-              </a:rPr>
-              <a:t>df.shape</a:t>
-            </a:r>
-            <a:endParaRPr lang="en-US" sz="2200" dirty="0"/>
-          </a:p>
-        </p:txBody>
-      </p:sp>
-      <p:sp>
-        <p:nvSpPr>
-          <p:cNvPr id="16" name="card-out"/>
-          <p:cNvSpPr/>
-          <p:nvPr/>
-        </p:nvSpPr>
-        <p:spPr>
-          <a:xfrm>
-            <a:off x="6263640" y="4069080"/>
-            <a:ext cx="5349240" cy="1188720"/>
-          </a:xfrm>
-          <a:prstGeom prst="roundRect">
-            <a:avLst>
-              <a:gd name="adj" fmla="val 9231"/>
-            </a:avLst>
-          </a:prstGeom>
-          <a:solidFill>
-            <a:srgbClr val="EEF3F4"/>
-          </a:solidFill>
-          <a:ln/>
-        </p:spPr>
-      </p:sp>
-      <p:sp>
-        <p:nvSpPr>
-          <p:cNvPr id="17" name="Text 15"/>
-          <p:cNvSpPr txBox="1"/>
-          <p:nvPr/>
-        </p:nvSpPr>
-        <p:spPr>
-          <a:xfrm>
-            <a:off x="6492240" y="4206240"/>
-            <a:ext cx="1828800" cy="274320"/>
-          </a:xfrm>
-          <a:prstGeom prst="rect">
-            <a:avLst/>
-          </a:prstGeom>
-          <a:noFill/>
-          <a:ln/>
-        </p:spPr>
-        <p:txBody>
-          <a:bodyPr wrap="square" lIns="0" tIns="0" rIns="0" bIns="0" rtlCol="0" anchor="ctr"/>
-          <a:lstStyle/>
-          <a:p>
-            <a:pPr indent="0" marL="0">
-              <a:buNone/>
-            </a:pPr>
-            <a:r>
-              <a:rPr lang="en-US" sz="1100" b="1" spc="200" kern="0" dirty="0">
-                <a:solidFill>
-                  <a:srgbClr val="5C6F7B"/>
-                </a:solidFill>
-              </a:rPr>
-              <a:t>OUTPUT</a:t>
-            </a:r>
-            <a:endParaRPr lang="en-US" sz="1100" dirty="0"/>
-          </a:p>
-        </p:txBody>
-      </p:sp>
-      <p:sp>
-        <p:nvSpPr>
-          <p:cNvPr id="18" name="Text 16"/>
-          <p:cNvSpPr txBox="1"/>
-          <p:nvPr/>
-        </p:nvSpPr>
-        <p:spPr>
-          <a:xfrm>
-            <a:off x="6492240" y="4526280"/>
-            <a:ext cx="4892040" cy="594360"/>
-          </a:xfrm>
-          <a:prstGeom prst="rect">
-            <a:avLst/>
-          </a:prstGeom>
-          <a:noFill/>
-          <a:ln/>
-        </p:spPr>
-        <p:txBody>
-          <a:bodyPr wrap="square" lIns="0" tIns="0" rIns="0" bIns="0" rtlCol="0" anchor="t"/>
-          <a:lstStyle/>
-          <a:p>
-            <a:pPr indent="0" marL="0">
-              <a:buNone/>
-            </a:pPr>
-            <a:r>
-              <a:rPr lang="en-US" sz="2000" dirty="0">
-                <a:solidFill>
-                  <a:srgbClr val="1F2A30"/>
-                </a:solidFill>
-                <a:latin typeface="Courier New" pitchFamily="34" charset="0"/>
-                <a:ea typeface="Courier New" pitchFamily="34" charset="-122"/>
-                <a:cs typeface="Courier New" pitchFamily="34" charset="-120"/>
-              </a:rPr>
-              <a:t>(2515, 9)</a:t>
-            </a:r>
-            <a:endParaRPr lang="en-US" sz="2000" dirty="0"/>
-          </a:p>
-        </p:txBody>
-      </p:sp>
-      <p:sp>
-        <p:nvSpPr>
-          <p:cNvPr id="19" name="Text 17"/>
-          <p:cNvSpPr txBox="1"/>
-          <p:nvPr/>
-        </p:nvSpPr>
-        <p:spPr>
-          <a:xfrm>
-            <a:off x="548640" y="5532120"/>
-            <a:ext cx="11064240" cy="457200"/>
-          </a:xfrm>
-          <a:prstGeom prst="rect">
-            <a:avLst/>
-          </a:prstGeom>
-          <a:noFill/>
-          <a:ln/>
-        </p:spPr>
-        <p:txBody>
-          <a:bodyPr wrap="square" lIns="0" tIns="0" rIns="0" bIns="0" rtlCol="0" anchor="ctr"/>
-          <a:lstStyle/>
-          <a:p>
-            <a:pPr indent="0" marL="0">
-              <a:buNone/>
-            </a:pPr>
-            <a:r>
-              <a:rPr lang="en-US" sz="1800" i="1" dirty="0">
-                <a:solidFill>
-                  <a:srgbClr val="0F4C5C"/>
-                </a:solidFill>
-              </a:rPr>
-              <a:t>df è un oggetto: dati, più tutte le cose che puoi chiedergli. Il punto le collega.</a:t>
-            </a:r>
-            <a:endParaRPr lang="en-US" sz="1800" dirty="0"/>
           </a:p>
         </p:txBody>
       </p:sp>

</xml_diff>